<commit_message>
adjust test code and enhance frontend - login, add post
</commit_message>
<xml_diff>
--- a/note/frontend_page_plan.pptx
+++ b/note/frontend_page_plan.pptx
@@ -5,12 +5,15 @@
     <p:sldMasterId id="2147483648" r:id="rId1"/>
   </p:sldMasterIdLst>
   <p:notesMasterIdLst>
-    <p:notesMasterId r:id="rId5"/>
+    <p:notesMasterId r:id="rId8"/>
   </p:notesMasterIdLst>
   <p:sldIdLst>
     <p:sldId id="256" r:id="rId2"/>
-    <p:sldId id="257" r:id="rId3"/>
-    <p:sldId id="258" r:id="rId4"/>
+    <p:sldId id="261" r:id="rId3"/>
+    <p:sldId id="260" r:id="rId4"/>
+    <p:sldId id="262" r:id="rId5"/>
+    <p:sldId id="257" r:id="rId6"/>
+    <p:sldId id="258" r:id="rId7"/>
   </p:sldIdLst>
   <p:sldSz cx="9144000" cy="6858000" type="screen4x3"/>
   <p:notesSz cx="6858000" cy="9144000"/>
@@ -195,7 +198,7 @@
             <a:fld id="{C7B2C064-4715-42BE-8447-58F43F0E67E0}" type="datetimeFigureOut">
               <a:rPr lang="ko-KR" altLang="en-US" smtClean="0"/>
               <a:pPr/>
-              <a:t>2026-04-20</a:t>
+              <a:t>2026-05-10</a:t>
             </a:fld>
             <a:endParaRPr lang="ko-KR" altLang="en-US"/>
           </a:p>
@@ -619,26 +622,22 @@
           <a:p>
             <a:r>
               <a:rPr lang="ko-KR" altLang="en-US" smtClean="0"/>
-              <a:t>좌측 일기 탭을 눌렀을 때 화면</a:t>
-            </a:r>
-            <a:r>
-              <a:rPr lang="en-US" altLang="ko-KR" smtClean="0"/>
+              <a:t>좌측 하단 게스트 프로필</a:t>
+            </a:r>
+            <a:r>
+              <a:rPr lang="ko-KR" altLang="en-US" baseline="0" smtClean="0"/>
+              <a:t> 버튼을 눌러서 로그인 모달 대화창이 뜨게 한다</a:t>
+            </a:r>
+            <a:r>
+              <a:rPr lang="en-US" altLang="ko-KR" baseline="0" smtClean="0"/>
               <a:t>. </a:t>
             </a:r>
             <a:r>
-              <a:rPr lang="ko-KR" altLang="en-US" smtClean="0"/>
-              <a:t>가장 빠른 연도의 일기들이 표시 되게 하며</a:t>
-            </a:r>
-            <a:r>
-              <a:rPr lang="en-US" altLang="ko-KR" smtClean="0"/>
-              <a:t>, </a:t>
-            </a:r>
-            <a:r>
-              <a:rPr lang="ko-KR" altLang="en-US" smtClean="0"/>
-              <a:t>우측에서 연도별 일기를 선택할 수 있게 한다</a:t>
-            </a:r>
-            <a:r>
-              <a:rPr lang="en-US" altLang="ko-KR" smtClean="0"/>
+              <a:rPr lang="ko-KR" altLang="en-US" baseline="0" smtClean="0"/>
+              <a:t>이것으로 로그인 하여 브라우저가 일정 시간 동안 토큰을 품어 로그인 된 것으로 처리하게 한다</a:t>
+            </a:r>
+            <a:r>
+              <a:rPr lang="en-US" altLang="ko-KR" baseline="0" smtClean="0"/>
               <a:t>.</a:t>
             </a:r>
             <a:endParaRPr lang="ko-KR" altLang="en-US"/>
@@ -725,31 +724,56 @@
           <a:p>
             <a:r>
               <a:rPr lang="ko-KR" altLang="en-US" smtClean="0"/>
-              <a:t>좌측 일기 탭을 눌렀을 때 화면</a:t>
+              <a:t>로그인 하고 나면 좌측 하단의 프로필은 사용자</a:t>
+            </a:r>
+            <a:r>
+              <a:rPr lang="ko-KR" altLang="en-US" baseline="0" smtClean="0"/>
+              <a:t> 정보</a:t>
+            </a:r>
+            <a:r>
+              <a:rPr lang="en-US" altLang="ko-KR" baseline="0" smtClean="0"/>
+              <a:t>(</a:t>
+            </a:r>
+            <a:r>
+              <a:rPr lang="ko-KR" altLang="en-US" baseline="0" smtClean="0"/>
+              <a:t>이름</a:t>
+            </a:r>
+            <a:r>
+              <a:rPr lang="en-US" altLang="ko-KR" baseline="0" smtClean="0"/>
+              <a:t> </a:t>
+            </a:r>
+            <a:r>
+              <a:rPr lang="ko-KR" altLang="en-US" baseline="0" smtClean="0"/>
+              <a:t>또는 </a:t>
+            </a:r>
+            <a:r>
+              <a:rPr lang="en-US" altLang="ko-KR" baseline="0" smtClean="0"/>
+              <a:t>id)</a:t>
+            </a:r>
+            <a:r>
+              <a:rPr lang="ko-KR" altLang="en-US" baseline="0" smtClean="0"/>
+              <a:t>가 나타나게 한다</a:t>
+            </a:r>
+            <a:r>
+              <a:rPr lang="en-US" altLang="ko-KR" baseline="0" smtClean="0"/>
+              <a:t>.</a:t>
+            </a:r>
+          </a:p>
+          <a:p>
+            <a:endParaRPr lang="en-US" altLang="ko-KR" smtClean="0"/>
+          </a:p>
+          <a:p>
+            <a:r>
+              <a:rPr lang="ko-KR" altLang="en-US" smtClean="0"/>
+              <a:t>오른쪽의 녹색의 </a:t>
             </a:r>
             <a:r>
               <a:rPr lang="en-US" altLang="ko-KR" smtClean="0"/>
-              <a:t>. </a:t>
-            </a:r>
-            <a:r>
-              <a:rPr lang="ko-KR" altLang="en-US" smtClean="0"/>
-              <a:t>가장 빠른 연도의 일기들이 표시 되게 하며</a:t>
-            </a:r>
-            <a:r>
-              <a:rPr lang="en-US" altLang="ko-KR" smtClean="0"/>
-              <a:t>, </a:t>
-            </a:r>
-            <a:r>
-              <a:rPr lang="ko-KR" altLang="en-US" smtClean="0"/>
-              <a:t>우측에서 연도별 일기를 선택할 수 </a:t>
-            </a:r>
-            <a:r>
-              <a:rPr lang="ko-KR" altLang="en-US" smtClean="0"/>
-              <a:t>있게 </a:t>
-            </a:r>
-            <a:r>
-              <a:rPr lang="ko-KR" altLang="en-US" smtClean="0"/>
-              <a:t>한다</a:t>
+              <a:t>‘+’ </a:t>
+            </a:r>
+            <a:r>
+              <a:rPr lang="ko-KR" altLang="en-US" smtClean="0"/>
+              <a:t>버튼은 일기 추가로 쓰게 하는 버튼이며 로그인 했을 때만 활성화 되게 한다</a:t>
             </a:r>
             <a:r>
               <a:rPr lang="en-US" altLang="ko-KR" smtClean="0"/>
@@ -778,6 +802,380 @@
               <a:rPr lang="ko-KR" altLang="en-US" smtClean="0"/>
               <a:pPr/>
               <a:t>3</a:t>
+            </a:fld>
+            <a:endParaRPr lang="ko-KR" altLang="en-US"/>
+          </a:p>
+        </p:txBody>
+      </p:sp>
+    </p:spTree>
+  </p:cSld>
+  <p:clrMapOvr>
+    <a:masterClrMapping/>
+  </p:clrMapOvr>
+</p:notes>
+</file>
+
+<file path=ppt/notesSlides/notesSlide4.xml><?xml version="1.0" encoding="utf-8"?>
+<p:notes xmlns:a="http://schemas.openxmlformats.org/drawingml/2006/main" xmlns:r="http://schemas.openxmlformats.org/officeDocument/2006/relationships" xmlns:p="http://schemas.openxmlformats.org/presentationml/2006/main">
+  <p:cSld>
+    <p:spTree>
+      <p:nvGrpSpPr>
+        <p:cNvPr id="1" name=""/>
+        <p:cNvGrpSpPr/>
+        <p:nvPr/>
+      </p:nvGrpSpPr>
+      <p:grpSpPr>
+        <a:xfrm>
+          <a:off x="0" y="0"/>
+          <a:ext cx="0" cy="0"/>
+          <a:chOff x="0" y="0"/>
+          <a:chExt cx="0" cy="0"/>
+        </a:xfrm>
+      </p:grpSpPr>
+      <p:sp>
+        <p:nvSpPr>
+          <p:cNvPr id="2" name="슬라이드 이미지 개체 틀 1"/>
+          <p:cNvSpPr>
+            <a:spLocks noGrp="1" noRot="1" noChangeAspect="1"/>
+          </p:cNvSpPr>
+          <p:nvPr>
+            <p:ph type="sldImg"/>
+          </p:nvPr>
+        </p:nvSpPr>
+        <p:spPr/>
+      </p:sp>
+      <p:sp>
+        <p:nvSpPr>
+          <p:cNvPr id="3" name="슬라이드 노트 개체 틀 2"/>
+          <p:cNvSpPr>
+            <a:spLocks noGrp="1"/>
+          </p:cNvSpPr>
+          <p:nvPr>
+            <p:ph type="body" idx="1"/>
+          </p:nvPr>
+        </p:nvSpPr>
+        <p:spPr/>
+        <p:txBody>
+          <a:bodyPr>
+            <a:normAutofit/>
+          </a:bodyPr>
+          <a:lstStyle/>
+          <a:p>
+            <a:r>
+              <a:rPr lang="ko-KR" altLang="en-US" smtClean="0"/>
+              <a:t>녹색 원의 </a:t>
+            </a:r>
+            <a:r>
+              <a:rPr lang="en-US" altLang="ko-KR" smtClean="0"/>
+              <a:t>‘+’ </a:t>
+            </a:r>
+            <a:r>
+              <a:rPr lang="ko-KR" altLang="en-US" smtClean="0"/>
+              <a:t>단추를 눌렀을 때의 모달 대화창</a:t>
+            </a:r>
+            <a:r>
+              <a:rPr lang="en-US" altLang="ko-KR" smtClean="0"/>
+              <a:t>,</a:t>
+            </a:r>
+            <a:r>
+              <a:rPr lang="en-US" altLang="ko-KR" baseline="0" smtClean="0"/>
+              <a:t> </a:t>
+            </a:r>
+            <a:r>
+              <a:rPr lang="ko-KR" altLang="en-US" baseline="0" smtClean="0"/>
+              <a:t>일기를 입력한다</a:t>
+            </a:r>
+            <a:r>
+              <a:rPr lang="en-US" altLang="ko-KR" baseline="0" smtClean="0"/>
+              <a:t>. </a:t>
+            </a:r>
+            <a:r>
+              <a:rPr lang="ko-KR" altLang="en-US" baseline="0" smtClean="0"/>
+              <a:t>이때 입력되는 </a:t>
+            </a:r>
+            <a:r>
+              <a:rPr lang="en-US" altLang="ko-KR" baseline="0" smtClean="0"/>
+              <a:t>category</a:t>
+            </a:r>
+            <a:r>
+              <a:rPr lang="ko-KR" altLang="en-US" baseline="0" smtClean="0"/>
+              <a:t>는 </a:t>
+            </a:r>
+            <a:r>
+              <a:rPr lang="en-US" altLang="ko-KR" baseline="0" smtClean="0"/>
+              <a:t>‘1’(</a:t>
+            </a:r>
+            <a:r>
+              <a:rPr lang="ko-KR" altLang="en-US" baseline="0" smtClean="0"/>
+              <a:t>일기</a:t>
+            </a:r>
+            <a:r>
+              <a:rPr lang="en-US" altLang="ko-KR" baseline="0" smtClean="0"/>
+              <a:t>). </a:t>
+            </a:r>
+            <a:r>
+              <a:rPr lang="ko-KR" altLang="en-US" baseline="0" smtClean="0"/>
+              <a:t>날짜 선택창은 </a:t>
+            </a:r>
+            <a:r>
+              <a:rPr lang="en-US" altLang="ko-KR" baseline="0" smtClean="0"/>
+              <a:t>postDate</a:t>
+            </a:r>
+            <a:r>
+              <a:rPr lang="ko-KR" altLang="en-US" baseline="0" smtClean="0"/>
+              <a:t>값에 기반 한다</a:t>
+            </a:r>
+            <a:r>
+              <a:rPr lang="en-US" altLang="ko-KR" baseline="0" smtClean="0"/>
+              <a:t>. </a:t>
+            </a:r>
+            <a:r>
+              <a:rPr lang="ko-KR" altLang="en-US" baseline="0" smtClean="0"/>
+              <a:t>제목은 입력하지 않으면 날짜 선택창과 같은 값을 기록한다</a:t>
+            </a:r>
+            <a:r>
+              <a:rPr lang="en-US" altLang="ko-KR" baseline="0" smtClean="0"/>
+              <a:t>.</a:t>
+            </a:r>
+            <a:endParaRPr lang="ko-KR" altLang="en-US"/>
+          </a:p>
+        </p:txBody>
+      </p:sp>
+      <p:sp>
+        <p:nvSpPr>
+          <p:cNvPr id="4" name="슬라이드 번호 개체 틀 3"/>
+          <p:cNvSpPr>
+            <a:spLocks noGrp="1"/>
+          </p:cNvSpPr>
+          <p:nvPr>
+            <p:ph type="sldNum" sz="quarter" idx="10"/>
+          </p:nvPr>
+        </p:nvSpPr>
+        <p:spPr/>
+        <p:txBody>
+          <a:bodyPr/>
+          <a:lstStyle/>
+          <a:p>
+            <a:fld id="{7C809E1A-CE74-4C2A-A20D-C7CAF9A7E1D0}" type="slidenum">
+              <a:rPr lang="ko-KR" altLang="en-US" smtClean="0"/>
+              <a:pPr/>
+              <a:t>4</a:t>
+            </a:fld>
+            <a:endParaRPr lang="ko-KR" altLang="en-US"/>
+          </a:p>
+        </p:txBody>
+      </p:sp>
+    </p:spTree>
+  </p:cSld>
+  <p:clrMapOvr>
+    <a:masterClrMapping/>
+  </p:clrMapOvr>
+</p:notes>
+</file>
+
+<file path=ppt/notesSlides/notesSlide5.xml><?xml version="1.0" encoding="utf-8"?>
+<p:notes xmlns:a="http://schemas.openxmlformats.org/drawingml/2006/main" xmlns:r="http://schemas.openxmlformats.org/officeDocument/2006/relationships" xmlns:p="http://schemas.openxmlformats.org/presentationml/2006/main">
+  <p:cSld>
+    <p:spTree>
+      <p:nvGrpSpPr>
+        <p:cNvPr id="1" name=""/>
+        <p:cNvGrpSpPr/>
+        <p:nvPr/>
+      </p:nvGrpSpPr>
+      <p:grpSpPr>
+        <a:xfrm>
+          <a:off x="0" y="0"/>
+          <a:ext cx="0" cy="0"/>
+          <a:chOff x="0" y="0"/>
+          <a:chExt cx="0" cy="0"/>
+        </a:xfrm>
+      </p:grpSpPr>
+      <p:sp>
+        <p:nvSpPr>
+          <p:cNvPr id="2" name="슬라이드 이미지 개체 틀 1"/>
+          <p:cNvSpPr>
+            <a:spLocks noGrp="1" noRot="1" noChangeAspect="1"/>
+          </p:cNvSpPr>
+          <p:nvPr>
+            <p:ph type="sldImg"/>
+          </p:nvPr>
+        </p:nvSpPr>
+        <p:spPr/>
+      </p:sp>
+      <p:sp>
+        <p:nvSpPr>
+          <p:cNvPr id="3" name="슬라이드 노트 개체 틀 2"/>
+          <p:cNvSpPr>
+            <a:spLocks noGrp="1"/>
+          </p:cNvSpPr>
+          <p:nvPr>
+            <p:ph type="body" idx="1"/>
+          </p:nvPr>
+        </p:nvSpPr>
+        <p:spPr/>
+        <p:txBody>
+          <a:bodyPr>
+            <a:normAutofit/>
+          </a:bodyPr>
+          <a:lstStyle/>
+          <a:p>
+            <a:r>
+              <a:rPr lang="ko-KR" altLang="en-US" smtClean="0"/>
+              <a:t>좌측 일기 탭을 눌렀을 때 화면</a:t>
+            </a:r>
+            <a:r>
+              <a:rPr lang="en-US" altLang="ko-KR" smtClean="0"/>
+              <a:t>. </a:t>
+            </a:r>
+            <a:r>
+              <a:rPr lang="ko-KR" altLang="en-US" smtClean="0"/>
+              <a:t>가장 빠른 연도의 일기들이 표시 되게 하며</a:t>
+            </a:r>
+            <a:r>
+              <a:rPr lang="en-US" altLang="ko-KR" smtClean="0"/>
+              <a:t>, </a:t>
+            </a:r>
+            <a:r>
+              <a:rPr lang="ko-KR" altLang="en-US" smtClean="0"/>
+              <a:t>우측에서 연도별 일기를 선택할 수 있게 한다</a:t>
+            </a:r>
+            <a:r>
+              <a:rPr lang="en-US" altLang="ko-KR" smtClean="0"/>
+              <a:t>.</a:t>
+            </a:r>
+            <a:endParaRPr lang="ko-KR" altLang="en-US"/>
+          </a:p>
+        </p:txBody>
+      </p:sp>
+      <p:sp>
+        <p:nvSpPr>
+          <p:cNvPr id="4" name="슬라이드 번호 개체 틀 3"/>
+          <p:cNvSpPr>
+            <a:spLocks noGrp="1"/>
+          </p:cNvSpPr>
+          <p:nvPr>
+            <p:ph type="sldNum" sz="quarter" idx="10"/>
+          </p:nvPr>
+        </p:nvSpPr>
+        <p:spPr/>
+        <p:txBody>
+          <a:bodyPr/>
+          <a:lstStyle/>
+          <a:p>
+            <a:fld id="{7C809E1A-CE74-4C2A-A20D-C7CAF9A7E1D0}" type="slidenum">
+              <a:rPr lang="ko-KR" altLang="en-US" smtClean="0"/>
+              <a:pPr/>
+              <a:t>5</a:t>
+            </a:fld>
+            <a:endParaRPr lang="ko-KR" altLang="en-US"/>
+          </a:p>
+        </p:txBody>
+      </p:sp>
+    </p:spTree>
+  </p:cSld>
+  <p:clrMapOvr>
+    <a:masterClrMapping/>
+  </p:clrMapOvr>
+</p:notes>
+</file>
+
+<file path=ppt/notesSlides/notesSlide6.xml><?xml version="1.0" encoding="utf-8"?>
+<p:notes xmlns:a="http://schemas.openxmlformats.org/drawingml/2006/main" xmlns:r="http://schemas.openxmlformats.org/officeDocument/2006/relationships" xmlns:p="http://schemas.openxmlformats.org/presentationml/2006/main">
+  <p:cSld>
+    <p:spTree>
+      <p:nvGrpSpPr>
+        <p:cNvPr id="1" name=""/>
+        <p:cNvGrpSpPr/>
+        <p:nvPr/>
+      </p:nvGrpSpPr>
+      <p:grpSpPr>
+        <a:xfrm>
+          <a:off x="0" y="0"/>
+          <a:ext cx="0" cy="0"/>
+          <a:chOff x="0" y="0"/>
+          <a:chExt cx="0" cy="0"/>
+        </a:xfrm>
+      </p:grpSpPr>
+      <p:sp>
+        <p:nvSpPr>
+          <p:cNvPr id="2" name="슬라이드 이미지 개체 틀 1"/>
+          <p:cNvSpPr>
+            <a:spLocks noGrp="1" noRot="1" noChangeAspect="1"/>
+          </p:cNvSpPr>
+          <p:nvPr>
+            <p:ph type="sldImg"/>
+          </p:nvPr>
+        </p:nvSpPr>
+        <p:spPr/>
+      </p:sp>
+      <p:sp>
+        <p:nvSpPr>
+          <p:cNvPr id="3" name="슬라이드 노트 개체 틀 2"/>
+          <p:cNvSpPr>
+            <a:spLocks noGrp="1"/>
+          </p:cNvSpPr>
+          <p:nvPr>
+            <p:ph type="body" idx="1"/>
+          </p:nvPr>
+        </p:nvSpPr>
+        <p:spPr/>
+        <p:txBody>
+          <a:bodyPr>
+            <a:normAutofit/>
+          </a:bodyPr>
+          <a:lstStyle/>
+          <a:p>
+            <a:r>
+              <a:rPr lang="ko-KR" altLang="en-US" smtClean="0"/>
+              <a:t>글을 눌렀을 때의 화면</a:t>
+            </a:r>
+            <a:r>
+              <a:rPr lang="en-US" altLang="ko-KR" smtClean="0"/>
+              <a:t>. </a:t>
+            </a:r>
+            <a:r>
+              <a:rPr lang="ko-KR" altLang="en-US" smtClean="0"/>
+              <a:t>다른 카테고리의 글을 볼 수 있게 하고</a:t>
+            </a:r>
+            <a:r>
+              <a:rPr lang="en-US" altLang="ko-KR" smtClean="0"/>
+              <a:t>, </a:t>
+            </a:r>
+            <a:r>
+              <a:rPr lang="ko-KR" altLang="en-US" smtClean="0"/>
+              <a:t>우측에는</a:t>
+            </a:r>
+            <a:r>
+              <a:rPr lang="ko-KR" altLang="en-US" baseline="0" smtClean="0"/>
+              <a:t> 카테고리 선택 창이 있게 한다</a:t>
+            </a:r>
+            <a:r>
+              <a:rPr lang="en-US" altLang="ko-KR" baseline="0" smtClean="0"/>
+              <a:t>.</a:t>
+            </a:r>
+            <a:endParaRPr lang="ko-KR" altLang="en-US"/>
+          </a:p>
+        </p:txBody>
+      </p:sp>
+      <p:sp>
+        <p:nvSpPr>
+          <p:cNvPr id="4" name="슬라이드 번호 개체 틀 3"/>
+          <p:cNvSpPr>
+            <a:spLocks noGrp="1"/>
+          </p:cNvSpPr>
+          <p:nvPr>
+            <p:ph type="sldNum" sz="quarter" idx="10"/>
+          </p:nvPr>
+        </p:nvSpPr>
+        <p:spPr/>
+        <p:txBody>
+          <a:bodyPr/>
+          <a:lstStyle/>
+          <a:p>
+            <a:fld id="{7C809E1A-CE74-4C2A-A20D-C7CAF9A7E1D0}" type="slidenum">
+              <a:rPr lang="ko-KR" altLang="en-US" smtClean="0"/>
+              <a:pPr/>
+              <a:t>6</a:t>
             </a:fld>
             <a:endParaRPr lang="ko-KR" altLang="en-US"/>
           </a:p>
@@ -973,7 +1371,7 @@
             <a:fld id="{49BCE5CC-EAE8-48BE-852D-E6A066A35CB1}" type="datetimeFigureOut">
               <a:rPr lang="ko-KR" altLang="en-US" smtClean="0"/>
               <a:pPr/>
-              <a:t>2026-04-20</a:t>
+              <a:t>2026-05-10</a:t>
             </a:fld>
             <a:endParaRPr lang="ko-KR" altLang="en-US"/>
           </a:p>
@@ -1140,7 +1538,7 @@
             <a:fld id="{49BCE5CC-EAE8-48BE-852D-E6A066A35CB1}" type="datetimeFigureOut">
               <a:rPr lang="ko-KR" altLang="en-US" smtClean="0"/>
               <a:pPr/>
-              <a:t>2026-04-20</a:t>
+              <a:t>2026-05-10</a:t>
             </a:fld>
             <a:endParaRPr lang="ko-KR" altLang="en-US"/>
           </a:p>
@@ -1317,7 +1715,7 @@
             <a:fld id="{49BCE5CC-EAE8-48BE-852D-E6A066A35CB1}" type="datetimeFigureOut">
               <a:rPr lang="ko-KR" altLang="en-US" smtClean="0"/>
               <a:pPr/>
-              <a:t>2026-04-20</a:t>
+              <a:t>2026-05-10</a:t>
             </a:fld>
             <a:endParaRPr lang="ko-KR" altLang="en-US"/>
           </a:p>
@@ -1484,7 +1882,7 @@
             <a:fld id="{49BCE5CC-EAE8-48BE-852D-E6A066A35CB1}" type="datetimeFigureOut">
               <a:rPr lang="ko-KR" altLang="en-US" smtClean="0"/>
               <a:pPr/>
-              <a:t>2026-04-20</a:t>
+              <a:t>2026-05-10</a:t>
             </a:fld>
             <a:endParaRPr lang="ko-KR" altLang="en-US"/>
           </a:p>
@@ -1727,7 +2125,7 @@
             <a:fld id="{49BCE5CC-EAE8-48BE-852D-E6A066A35CB1}" type="datetimeFigureOut">
               <a:rPr lang="ko-KR" altLang="en-US" smtClean="0"/>
               <a:pPr/>
-              <a:t>2026-04-20</a:t>
+              <a:t>2026-05-10</a:t>
             </a:fld>
             <a:endParaRPr lang="ko-KR" altLang="en-US"/>
           </a:p>
@@ -2012,7 +2410,7 @@
             <a:fld id="{49BCE5CC-EAE8-48BE-852D-E6A066A35CB1}" type="datetimeFigureOut">
               <a:rPr lang="ko-KR" altLang="en-US" smtClean="0"/>
               <a:pPr/>
-              <a:t>2026-04-20</a:t>
+              <a:t>2026-05-10</a:t>
             </a:fld>
             <a:endParaRPr lang="ko-KR" altLang="en-US"/>
           </a:p>
@@ -2431,7 +2829,7 @@
             <a:fld id="{49BCE5CC-EAE8-48BE-852D-E6A066A35CB1}" type="datetimeFigureOut">
               <a:rPr lang="ko-KR" altLang="en-US" smtClean="0"/>
               <a:pPr/>
-              <a:t>2026-04-20</a:t>
+              <a:t>2026-05-10</a:t>
             </a:fld>
             <a:endParaRPr lang="ko-KR" altLang="en-US"/>
           </a:p>
@@ -2546,7 +2944,7 @@
             <a:fld id="{49BCE5CC-EAE8-48BE-852D-E6A066A35CB1}" type="datetimeFigureOut">
               <a:rPr lang="ko-KR" altLang="en-US" smtClean="0"/>
               <a:pPr/>
-              <a:t>2026-04-20</a:t>
+              <a:t>2026-05-10</a:t>
             </a:fld>
             <a:endParaRPr lang="ko-KR" altLang="en-US"/>
           </a:p>
@@ -2638,7 +3036,7 @@
             <a:fld id="{49BCE5CC-EAE8-48BE-852D-E6A066A35CB1}" type="datetimeFigureOut">
               <a:rPr lang="ko-KR" altLang="en-US" smtClean="0"/>
               <a:pPr/>
-              <a:t>2026-04-20</a:t>
+              <a:t>2026-05-10</a:t>
             </a:fld>
             <a:endParaRPr lang="ko-KR" altLang="en-US"/>
           </a:p>
@@ -2912,7 +3310,7 @@
             <a:fld id="{49BCE5CC-EAE8-48BE-852D-E6A066A35CB1}" type="datetimeFigureOut">
               <a:rPr lang="ko-KR" altLang="en-US" smtClean="0"/>
               <a:pPr/>
-              <a:t>2026-04-20</a:t>
+              <a:t>2026-05-10</a:t>
             </a:fld>
             <a:endParaRPr lang="ko-KR" altLang="en-US"/>
           </a:p>
@@ -3162,7 +3560,7 @@
             <a:fld id="{49BCE5CC-EAE8-48BE-852D-E6A066A35CB1}" type="datetimeFigureOut">
               <a:rPr lang="ko-KR" altLang="en-US" smtClean="0"/>
               <a:pPr/>
-              <a:t>2026-04-20</a:t>
+              <a:t>2026-05-10</a:t>
             </a:fld>
             <a:endParaRPr lang="ko-KR" altLang="en-US"/>
           </a:p>
@@ -3372,7 +3770,7 @@
             <a:fld id="{49BCE5CC-EAE8-48BE-852D-E6A066A35CB1}" type="datetimeFigureOut">
               <a:rPr lang="ko-KR" altLang="en-US" smtClean="0"/>
               <a:pPr/>
-              <a:t>2026-04-20</a:t>
+              <a:t>2026-05-10</a:t>
             </a:fld>
             <a:endParaRPr lang="ko-KR" altLang="en-US"/>
           </a:p>
@@ -3830,7 +4228,7 @@
         <p:spPr>
           <a:xfrm>
             <a:off x="755576" y="6237312"/>
-            <a:ext cx="877163" cy="369332"/>
+            <a:ext cx="782587" cy="369332"/>
           </a:xfrm>
           <a:prstGeom prst="rect">
             <a:avLst/>
@@ -3844,8 +4242,8 @@
           <a:lstStyle/>
           <a:p>
             <a:r>
-              <a:rPr lang="ko-KR" altLang="en-US" smtClean="0"/>
-              <a:t>이민혁</a:t>
+              <a:rPr lang="en-US" altLang="ko-KR" smtClean="0"/>
+              <a:t>Guest</a:t>
             </a:r>
             <a:endParaRPr lang="ko-KR" altLang="en-US"/>
           </a:p>
@@ -4391,7 +4789,7 @@
         <p:spPr>
           <a:xfrm>
             <a:off x="755576" y="6237312"/>
-            <a:ext cx="877163" cy="369332"/>
+            <a:ext cx="782587" cy="369332"/>
           </a:xfrm>
           <a:prstGeom prst="rect">
             <a:avLst/>
@@ -4405,23 +4803,23 @@
           <a:lstStyle/>
           <a:p>
             <a:r>
-              <a:rPr lang="ko-KR" altLang="en-US" smtClean="0"/>
-              <a:t>이민혁</a:t>
-            </a:r>
-            <a:endParaRPr lang="ko-KR" altLang="en-US"/>
-          </a:p>
-        </p:txBody>
-      </p:sp>
-      <p:sp>
-        <p:nvSpPr>
-          <p:cNvPr id="7" name="TextBox 6"/>
+              <a:rPr lang="en-US" altLang="ko-KR" smtClean="0"/>
+              <a:t>Guest</a:t>
+            </a:r>
+            <a:endParaRPr lang="ko-KR" altLang="en-US"/>
+          </a:p>
+        </p:txBody>
+      </p:sp>
+      <p:sp>
+        <p:nvSpPr>
+          <p:cNvPr id="9" name="TextBox 8"/>
           <p:cNvSpPr txBox="1"/>
           <p:nvPr/>
         </p:nvSpPr>
         <p:spPr>
           <a:xfrm>
-            <a:off x="107504" y="971436"/>
-            <a:ext cx="646331" cy="369332"/>
+            <a:off x="2627784" y="404664"/>
+            <a:ext cx="1005403" cy="400110"/>
           </a:xfrm>
           <a:prstGeom prst="rect">
             <a:avLst/>
@@ -4435,23 +4833,27 @@
           <a:lstStyle/>
           <a:p>
             <a:r>
-              <a:rPr lang="ko-KR" altLang="en-US" b="1" smtClean="0"/>
-              <a:t>일기</a:t>
-            </a:r>
-            <a:endParaRPr lang="ko-KR" altLang="en-US" b="1"/>
-          </a:p>
-        </p:txBody>
-      </p:sp>
-      <p:sp>
-        <p:nvSpPr>
-          <p:cNvPr id="8" name="TextBox 7"/>
+              <a:rPr lang="en-US" altLang="ko-KR" sz="2000" smtClean="0"/>
+              <a:t>2026</a:t>
+            </a:r>
+            <a:r>
+              <a:rPr lang="ko-KR" altLang="en-US" sz="2000" smtClean="0"/>
+              <a:t>년</a:t>
+            </a:r>
+            <a:endParaRPr lang="ko-KR" altLang="en-US" sz="2000"/>
+          </a:p>
+        </p:txBody>
+      </p:sp>
+      <p:sp>
+        <p:nvSpPr>
+          <p:cNvPr id="14" name="TextBox 13"/>
           <p:cNvSpPr txBox="1"/>
           <p:nvPr/>
         </p:nvSpPr>
         <p:spPr>
           <a:xfrm>
-            <a:off x="179512" y="1403484"/>
-            <a:ext cx="415498" cy="369332"/>
+            <a:off x="2771800" y="836712"/>
+            <a:ext cx="542136" cy="369332"/>
           </a:xfrm>
           <a:prstGeom prst="rect">
             <a:avLst/>
@@ -4465,23 +4867,27 @@
           <a:lstStyle/>
           <a:p>
             <a:r>
-              <a:rPr lang="ko-KR" altLang="en-US" smtClean="0"/>
-              <a:t>글</a:t>
-            </a:r>
-            <a:endParaRPr lang="ko-KR" altLang="en-US"/>
-          </a:p>
-        </p:txBody>
-      </p:sp>
-      <p:sp>
-        <p:nvSpPr>
-          <p:cNvPr id="9" name="TextBox 8"/>
+              <a:rPr lang="en-US" altLang="ko-KR" smtClean="0"/>
+              <a:t>2</a:t>
+            </a:r>
+            <a:r>
+              <a:rPr lang="ko-KR" altLang="en-US" smtClean="0"/>
+              <a:t>월</a:t>
+            </a:r>
+            <a:endParaRPr lang="ko-KR" altLang="en-US"/>
+          </a:p>
+        </p:txBody>
+      </p:sp>
+      <p:sp>
+        <p:nvSpPr>
+          <p:cNvPr id="16" name="TextBox 15"/>
           <p:cNvSpPr txBox="1"/>
           <p:nvPr/>
         </p:nvSpPr>
         <p:spPr>
           <a:xfrm>
-            <a:off x="2627784" y="404664"/>
-            <a:ext cx="1005403" cy="400110"/>
+            <a:off x="3059832" y="1268760"/>
+            <a:ext cx="617477" cy="338554"/>
           </a:xfrm>
           <a:prstGeom prst="rect">
             <a:avLst/>
@@ -4495,27 +4901,27 @@
           <a:lstStyle/>
           <a:p>
             <a:r>
-              <a:rPr lang="en-US" altLang="ko-KR" sz="2000" smtClean="0"/>
-              <a:t>2026</a:t>
-            </a:r>
-            <a:r>
-              <a:rPr lang="ko-KR" altLang="en-US" sz="2000" smtClean="0"/>
-              <a:t>년</a:t>
-            </a:r>
-            <a:endParaRPr lang="ko-KR" altLang="en-US" sz="2000"/>
-          </a:p>
-        </p:txBody>
-      </p:sp>
-      <p:sp>
-        <p:nvSpPr>
-          <p:cNvPr id="10" name="TextBox 9"/>
+              <a:rPr lang="en-US" altLang="ko-KR" sz="1600" smtClean="0"/>
+              <a:t>15</a:t>
+            </a:r>
+            <a:r>
+              <a:rPr lang="ko-KR" altLang="en-US" sz="1600" smtClean="0"/>
+              <a:t>일</a:t>
+            </a:r>
+            <a:endParaRPr lang="ko-KR" altLang="en-US" sz="1600"/>
+          </a:p>
+        </p:txBody>
+      </p:sp>
+      <p:sp>
+        <p:nvSpPr>
+          <p:cNvPr id="17" name="TextBox 16"/>
           <p:cNvSpPr txBox="1"/>
           <p:nvPr/>
         </p:nvSpPr>
         <p:spPr>
           <a:xfrm>
-            <a:off x="2843808" y="836712"/>
-            <a:ext cx="542136" cy="369332"/>
+            <a:off x="3275856" y="1700808"/>
+            <a:ext cx="2518638" cy="307777"/>
           </a:xfrm>
           <a:prstGeom prst="rect">
             <a:avLst/>
@@ -4529,249 +4935,16 @@
           <a:lstStyle/>
           <a:p>
             <a:r>
-              <a:rPr lang="en-US" altLang="ko-KR" smtClean="0"/>
-              <a:t>1</a:t>
-            </a:r>
-            <a:r>
-              <a:rPr lang="ko-KR" altLang="en-US" smtClean="0"/>
-              <a:t>월</a:t>
-            </a:r>
-            <a:endParaRPr lang="ko-KR" altLang="en-US"/>
-          </a:p>
-        </p:txBody>
-      </p:sp>
-      <p:sp>
-        <p:nvSpPr>
-          <p:cNvPr id="11" name="TextBox 10"/>
-          <p:cNvSpPr txBox="1"/>
-          <p:nvPr/>
-        </p:nvSpPr>
-        <p:spPr>
-          <a:xfrm>
-            <a:off x="3059832" y="1196752"/>
-            <a:ext cx="503664" cy="338554"/>
-          </a:xfrm>
-          <a:prstGeom prst="rect">
-            <a:avLst/>
-          </a:prstGeom>
-          <a:noFill/>
-        </p:spPr>
-        <p:txBody>
-          <a:bodyPr wrap="none" rtlCol="0">
-            <a:spAutoFit/>
-          </a:bodyPr>
-          <a:lstStyle/>
-          <a:p>
-            <a:r>
-              <a:rPr lang="en-US" altLang="ko-KR" sz="1600" smtClean="0"/>
-              <a:t>4</a:t>
-            </a:r>
-            <a:r>
-              <a:rPr lang="ko-KR" altLang="en-US" sz="1600" smtClean="0"/>
-              <a:t>일</a:t>
-            </a:r>
-            <a:endParaRPr lang="ko-KR" altLang="en-US" sz="1600"/>
-          </a:p>
-        </p:txBody>
-      </p:sp>
-      <p:sp>
-        <p:nvSpPr>
-          <p:cNvPr id="12" name="TextBox 11"/>
-          <p:cNvSpPr txBox="1"/>
-          <p:nvPr/>
-        </p:nvSpPr>
-        <p:spPr>
-          <a:xfrm>
-            <a:off x="3059832" y="2060848"/>
-            <a:ext cx="617477" cy="338554"/>
-          </a:xfrm>
-          <a:prstGeom prst="rect">
-            <a:avLst/>
-          </a:prstGeom>
-          <a:noFill/>
-        </p:spPr>
-        <p:txBody>
-          <a:bodyPr wrap="none" rtlCol="0">
-            <a:spAutoFit/>
-          </a:bodyPr>
-          <a:lstStyle/>
-          <a:p>
-            <a:r>
-              <a:rPr lang="en-US" altLang="ko-KR" sz="1600" smtClean="0"/>
-              <a:t>12</a:t>
-            </a:r>
-            <a:r>
-              <a:rPr lang="ko-KR" altLang="en-US" sz="1600" smtClean="0"/>
-              <a:t>일</a:t>
-            </a:r>
-            <a:endParaRPr lang="ko-KR" altLang="en-US" sz="1600"/>
-          </a:p>
-        </p:txBody>
-      </p:sp>
-      <p:sp>
-        <p:nvSpPr>
-          <p:cNvPr id="13" name="TextBox 12"/>
-          <p:cNvSpPr txBox="1"/>
-          <p:nvPr/>
-        </p:nvSpPr>
-        <p:spPr>
-          <a:xfrm>
-            <a:off x="3275856" y="1628800"/>
-            <a:ext cx="3728906" cy="307777"/>
-          </a:xfrm>
-          <a:prstGeom prst="rect">
-            <a:avLst/>
-          </a:prstGeom>
-          <a:noFill/>
-        </p:spPr>
-        <p:txBody>
-          <a:bodyPr wrap="none" rtlCol="0">
-            <a:spAutoFit/>
-          </a:bodyPr>
-          <a:lstStyle/>
-          <a:p>
+              <a:rPr lang="en-US" altLang="ko-KR" sz="1400" smtClean="0"/>
+              <a:t>(</a:t>
+            </a:r>
             <a:r>
               <a:rPr lang="ko-KR" altLang="en-US" sz="1400" smtClean="0"/>
-              <a:t>새해 소원을 빌었는데 잘 이뤄질지 모르겠다</a:t>
-            </a:r>
-            <a:endParaRPr lang="ko-KR" altLang="en-US" sz="1400"/>
-          </a:p>
-        </p:txBody>
-      </p:sp>
-      <p:sp>
-        <p:nvSpPr>
-          <p:cNvPr id="14" name="TextBox 13"/>
-          <p:cNvSpPr txBox="1"/>
-          <p:nvPr/>
-        </p:nvSpPr>
-        <p:spPr>
-          <a:xfrm>
-            <a:off x="2771800" y="3212976"/>
-            <a:ext cx="542136" cy="369332"/>
-          </a:xfrm>
-          <a:prstGeom prst="rect">
-            <a:avLst/>
-          </a:prstGeom>
-          <a:noFill/>
-        </p:spPr>
-        <p:txBody>
-          <a:bodyPr wrap="none" rtlCol="0">
-            <a:spAutoFit/>
-          </a:bodyPr>
-          <a:lstStyle/>
-          <a:p>
-            <a:r>
-              <a:rPr lang="en-US" altLang="ko-KR" smtClean="0"/>
-              <a:t>2</a:t>
-            </a:r>
-            <a:r>
-              <a:rPr lang="ko-KR" altLang="en-US" smtClean="0"/>
-              <a:t>월</a:t>
-            </a:r>
-            <a:endParaRPr lang="ko-KR" altLang="en-US"/>
-          </a:p>
-        </p:txBody>
-      </p:sp>
-      <p:sp>
-        <p:nvSpPr>
-          <p:cNvPr id="15" name="TextBox 14"/>
-          <p:cNvSpPr txBox="1"/>
-          <p:nvPr/>
-        </p:nvSpPr>
-        <p:spPr>
-          <a:xfrm>
-            <a:off x="3275856" y="2420888"/>
-            <a:ext cx="1144865" cy="307777"/>
-          </a:xfrm>
-          <a:prstGeom prst="rect">
-            <a:avLst/>
-          </a:prstGeom>
-          <a:noFill/>
-        </p:spPr>
-        <p:txBody>
-          <a:bodyPr wrap="none" rtlCol="0">
-            <a:spAutoFit/>
-          </a:bodyPr>
-          <a:lstStyle/>
-          <a:p>
-            <a:r>
-              <a:rPr lang="ko-KR" altLang="en-US" sz="1400" smtClean="0"/>
-              <a:t>늦잠을 잤다</a:t>
-            </a:r>
-            <a:endParaRPr lang="ko-KR" altLang="en-US" sz="1400"/>
-          </a:p>
-        </p:txBody>
-      </p:sp>
-      <p:sp>
-        <p:nvSpPr>
-          <p:cNvPr id="16" name="TextBox 15"/>
-          <p:cNvSpPr txBox="1"/>
-          <p:nvPr/>
-        </p:nvSpPr>
-        <p:spPr>
-          <a:xfrm>
-            <a:off x="3059832" y="3645024"/>
-            <a:ext cx="617477" cy="338554"/>
-          </a:xfrm>
-          <a:prstGeom prst="rect">
-            <a:avLst/>
-          </a:prstGeom>
-          <a:noFill/>
-        </p:spPr>
-        <p:txBody>
-          <a:bodyPr wrap="none" rtlCol="0">
-            <a:spAutoFit/>
-          </a:bodyPr>
-          <a:lstStyle/>
-          <a:p>
-            <a:r>
-              <a:rPr lang="en-US" altLang="ko-KR" sz="1600" smtClean="0"/>
-              <a:t>15</a:t>
-            </a:r>
-            <a:r>
-              <a:rPr lang="ko-KR" altLang="en-US" sz="1600" smtClean="0"/>
-              <a:t>일</a:t>
-            </a:r>
-            <a:endParaRPr lang="ko-KR" altLang="en-US" sz="1600"/>
-          </a:p>
-        </p:txBody>
-      </p:sp>
-      <p:sp>
-        <p:nvSpPr>
-          <p:cNvPr id="17" name="TextBox 16"/>
-          <p:cNvSpPr txBox="1"/>
-          <p:nvPr/>
-        </p:nvSpPr>
-        <p:spPr>
-          <a:xfrm>
-            <a:off x="3275856" y="4077072"/>
-            <a:ext cx="3611886" cy="523220"/>
-          </a:xfrm>
-          <a:prstGeom prst="rect">
-            <a:avLst/>
-          </a:prstGeom>
-          <a:noFill/>
-        </p:spPr>
-        <p:txBody>
-          <a:bodyPr wrap="none" rtlCol="0">
-            <a:spAutoFit/>
-          </a:bodyPr>
-          <a:lstStyle/>
-          <a:p>
-            <a:r>
-              <a:rPr lang="ko-KR" altLang="en-US" sz="1400" smtClean="0"/>
-              <a:t>회사에서 일어나고 있는 일이 별로 마음에 </a:t>
+              <a:t>가장 빠른 날짜의 일기 내용</a:t>
             </a:r>
             <a:r>
               <a:rPr lang="en-US" altLang="ko-KR" sz="1400" smtClean="0"/>
-              <a:t/>
-            </a:r>
-            <a:br>
-              <a:rPr lang="en-US" altLang="ko-KR" sz="1400" smtClean="0"/>
-            </a:br>
-            <a:r>
-              <a:rPr lang="ko-KR" altLang="en-US" sz="1400" smtClean="0"/>
-              <a:t>들지 않는다</a:t>
+              <a:t>)</a:t>
             </a:r>
             <a:endParaRPr lang="ko-KR" altLang="en-US" sz="1400"/>
           </a:p>
@@ -4920,45 +5093,6 @@
           <a:p>
             <a:endParaRPr lang="en-US" altLang="ko-KR" smtClean="0"/>
           </a:p>
-          <a:p>
-            <a:r>
-              <a:rPr lang="en-US" altLang="ko-KR" smtClean="0"/>
-              <a:t>2026</a:t>
-            </a:r>
-            <a:r>
-              <a:rPr lang="ko-KR" altLang="en-US" smtClean="0"/>
-              <a:t>년</a:t>
-            </a:r>
-            <a:endParaRPr lang="en-US" altLang="ko-KR" smtClean="0"/>
-          </a:p>
-          <a:p>
-            <a:endParaRPr lang="en-US" altLang="ko-KR" smtClean="0"/>
-          </a:p>
-          <a:p>
-            <a:r>
-              <a:rPr lang="en-US" altLang="ko-KR" smtClean="0"/>
-              <a:t>2025</a:t>
-            </a:r>
-            <a:r>
-              <a:rPr lang="ko-KR" altLang="en-US" smtClean="0"/>
-              <a:t>년</a:t>
-            </a:r>
-            <a:endParaRPr lang="en-US" altLang="ko-KR" smtClean="0"/>
-          </a:p>
-          <a:p>
-            <a:endParaRPr lang="en-US" altLang="ko-KR" smtClean="0"/>
-          </a:p>
-          <a:p>
-            <a:r>
-              <a:rPr lang="en-US" altLang="ko-KR" smtClean="0"/>
-              <a:t>2024</a:t>
-            </a:r>
-            <a:r>
-              <a:rPr lang="ko-KR" altLang="en-US" smtClean="0"/>
-              <a:t>년</a:t>
-            </a:r>
-            <a:endParaRPr lang="en-US" altLang="ko-KR" smtClean="0"/>
-          </a:p>
         </p:txBody>
       </p:sp>
       <p:sp>
@@ -5017,14 +5151,14 @@
       </p:sp>
       <p:sp>
         <p:nvSpPr>
-          <p:cNvPr id="23" name="TextBox 22"/>
+          <p:cNvPr id="22" name="TextBox 21"/>
           <p:cNvSpPr txBox="1"/>
           <p:nvPr/>
         </p:nvSpPr>
         <p:spPr>
           <a:xfrm>
-            <a:off x="179512" y="611396"/>
-            <a:ext cx="415498" cy="369332"/>
+            <a:off x="107504" y="971436"/>
+            <a:ext cx="646331" cy="369332"/>
           </a:xfrm>
           <a:prstGeom prst="rect">
             <a:avLst/>
@@ -5038,9 +5172,422 @@
           <a:lstStyle/>
           <a:p>
             <a:r>
-              <a:rPr lang="ko-KR" altLang="en-US"/>
+              <a:rPr lang="ko-KR" altLang="en-US" smtClean="0"/>
+              <a:t>일기</a:t>
+            </a:r>
+            <a:endParaRPr lang="ko-KR" altLang="en-US"/>
+          </a:p>
+        </p:txBody>
+      </p:sp>
+      <p:sp>
+        <p:nvSpPr>
+          <p:cNvPr id="23" name="TextBox 22"/>
+          <p:cNvSpPr txBox="1"/>
+          <p:nvPr/>
+        </p:nvSpPr>
+        <p:spPr>
+          <a:xfrm>
+            <a:off x="179512" y="1403484"/>
+            <a:ext cx="415498" cy="369332"/>
+          </a:xfrm>
+          <a:prstGeom prst="rect">
+            <a:avLst/>
+          </a:prstGeom>
+          <a:noFill/>
+        </p:spPr>
+        <p:txBody>
+          <a:bodyPr wrap="none" rtlCol="0">
+            <a:spAutoFit/>
+          </a:bodyPr>
+          <a:lstStyle/>
+          <a:p>
+            <a:r>
+              <a:rPr lang="ko-KR" altLang="en-US" smtClean="0"/>
+              <a:t>글</a:t>
+            </a:r>
+            <a:endParaRPr lang="ko-KR" altLang="en-US"/>
+          </a:p>
+        </p:txBody>
+      </p:sp>
+      <p:sp>
+        <p:nvSpPr>
+          <p:cNvPr id="24" name="TextBox 23"/>
+          <p:cNvSpPr txBox="1"/>
+          <p:nvPr/>
+        </p:nvSpPr>
+        <p:spPr>
+          <a:xfrm>
+            <a:off x="179512" y="611396"/>
+            <a:ext cx="415498" cy="369332"/>
+          </a:xfrm>
+          <a:prstGeom prst="rect">
+            <a:avLst/>
+          </a:prstGeom>
+          <a:noFill/>
+        </p:spPr>
+        <p:txBody>
+          <a:bodyPr wrap="none" rtlCol="0">
+            <a:spAutoFit/>
+          </a:bodyPr>
+          <a:lstStyle/>
+          <a:p>
+            <a:r>
+              <a:rPr lang="ko-KR" altLang="en-US" b="1"/>
               <a:t>홈</a:t>
             </a:r>
+          </a:p>
+        </p:txBody>
+      </p:sp>
+      <p:sp>
+        <p:nvSpPr>
+          <p:cNvPr id="25" name="직사각형 24"/>
+          <p:cNvSpPr/>
+          <p:nvPr/>
+        </p:nvSpPr>
+        <p:spPr>
+          <a:xfrm>
+            <a:off x="0" y="0"/>
+            <a:ext cx="9144000" cy="7173416"/>
+          </a:xfrm>
+          <a:prstGeom prst="rect">
+            <a:avLst/>
+          </a:prstGeom>
+          <a:solidFill>
+            <a:schemeClr val="tx1">
+              <a:alpha val="46000"/>
+            </a:schemeClr>
+          </a:solidFill>
+        </p:spPr>
+        <p:style>
+          <a:lnRef idx="2">
+            <a:schemeClr val="accent1">
+              <a:shade val="50000"/>
+            </a:schemeClr>
+          </a:lnRef>
+          <a:fillRef idx="1">
+            <a:schemeClr val="accent1"/>
+          </a:fillRef>
+          <a:effectRef idx="0">
+            <a:schemeClr val="accent1"/>
+          </a:effectRef>
+          <a:fontRef idx="minor">
+            <a:schemeClr val="lt1"/>
+          </a:fontRef>
+        </p:style>
+        <p:txBody>
+          <a:bodyPr rtlCol="0" anchor="ctr"/>
+          <a:lstStyle/>
+          <a:p>
+            <a:pPr algn="ctr"/>
+            <a:endParaRPr lang="ko-KR" altLang="en-US"/>
+          </a:p>
+        </p:txBody>
+      </p:sp>
+      <p:sp>
+        <p:nvSpPr>
+          <p:cNvPr id="26" name="직사각형 25"/>
+          <p:cNvSpPr/>
+          <p:nvPr/>
+        </p:nvSpPr>
+        <p:spPr>
+          <a:xfrm>
+            <a:off x="3419872" y="2060848"/>
+            <a:ext cx="2376264" cy="2880320"/>
+          </a:xfrm>
+          <a:prstGeom prst="rect">
+            <a:avLst/>
+          </a:prstGeom>
+          <a:solidFill>
+            <a:schemeClr val="bg1">
+              <a:lumMod val="85000"/>
+            </a:schemeClr>
+          </a:solidFill>
+        </p:spPr>
+        <p:style>
+          <a:lnRef idx="2">
+            <a:schemeClr val="accent1"/>
+          </a:lnRef>
+          <a:fillRef idx="1">
+            <a:schemeClr val="lt1"/>
+          </a:fillRef>
+          <a:effectRef idx="0">
+            <a:schemeClr val="accent1"/>
+          </a:effectRef>
+          <a:fontRef idx="minor">
+            <a:schemeClr val="dk1"/>
+          </a:fontRef>
+        </p:style>
+        <p:txBody>
+          <a:bodyPr rtlCol="0" anchor="ctr"/>
+          <a:lstStyle/>
+          <a:p>
+            <a:pPr algn="ctr"/>
+            <a:endParaRPr lang="ko-KR" altLang="en-US"/>
+          </a:p>
+        </p:txBody>
+      </p:sp>
+      <p:sp>
+        <p:nvSpPr>
+          <p:cNvPr id="27" name="직사각형 26"/>
+          <p:cNvSpPr/>
+          <p:nvPr/>
+        </p:nvSpPr>
+        <p:spPr>
+          <a:xfrm>
+            <a:off x="3635896" y="3068960"/>
+            <a:ext cx="1368152" cy="360040"/>
+          </a:xfrm>
+          <a:prstGeom prst="rect">
+            <a:avLst/>
+          </a:prstGeom>
+          <a:solidFill>
+            <a:schemeClr val="bg1">
+              <a:lumMod val="95000"/>
+            </a:schemeClr>
+          </a:solidFill>
+        </p:spPr>
+        <p:style>
+          <a:lnRef idx="2">
+            <a:schemeClr val="accent1">
+              <a:shade val="50000"/>
+            </a:schemeClr>
+          </a:lnRef>
+          <a:fillRef idx="1">
+            <a:schemeClr val="accent1"/>
+          </a:fillRef>
+          <a:effectRef idx="0">
+            <a:schemeClr val="accent1"/>
+          </a:effectRef>
+          <a:fontRef idx="minor">
+            <a:schemeClr val="lt1"/>
+          </a:fontRef>
+        </p:style>
+        <p:txBody>
+          <a:bodyPr rtlCol="0" anchor="ctr"/>
+          <a:lstStyle/>
+          <a:p>
+            <a:r>
+              <a:rPr lang="en-US" altLang="ko-KR" sz="1200" smtClean="0">
+                <a:solidFill>
+                  <a:schemeClr val="tx1"/>
+                </a:solidFill>
+              </a:rPr>
+              <a:t>(id)</a:t>
+            </a:r>
+            <a:endParaRPr lang="ko-KR" altLang="en-US" sz="1200">
+              <a:solidFill>
+                <a:schemeClr val="tx1"/>
+              </a:solidFill>
+            </a:endParaRPr>
+          </a:p>
+        </p:txBody>
+      </p:sp>
+      <p:sp>
+        <p:nvSpPr>
+          <p:cNvPr id="28" name="직사각형 27"/>
+          <p:cNvSpPr/>
+          <p:nvPr/>
+        </p:nvSpPr>
+        <p:spPr>
+          <a:xfrm>
+            <a:off x="3635896" y="3573016"/>
+            <a:ext cx="1368152" cy="360040"/>
+          </a:xfrm>
+          <a:prstGeom prst="rect">
+            <a:avLst/>
+          </a:prstGeom>
+          <a:solidFill>
+            <a:schemeClr val="bg1">
+              <a:lumMod val="95000"/>
+            </a:schemeClr>
+          </a:solidFill>
+        </p:spPr>
+        <p:style>
+          <a:lnRef idx="2">
+            <a:schemeClr val="accent1">
+              <a:shade val="50000"/>
+            </a:schemeClr>
+          </a:lnRef>
+          <a:fillRef idx="1">
+            <a:schemeClr val="accent1"/>
+          </a:fillRef>
+          <a:effectRef idx="0">
+            <a:schemeClr val="accent1"/>
+          </a:effectRef>
+          <a:fontRef idx="minor">
+            <a:schemeClr val="lt1"/>
+          </a:fontRef>
+        </p:style>
+        <p:txBody>
+          <a:bodyPr rtlCol="0" anchor="ctr"/>
+          <a:lstStyle/>
+          <a:p>
+            <a:r>
+              <a:rPr lang="en-US" altLang="ko-KR" sz="1200" smtClean="0">
+                <a:solidFill>
+                  <a:schemeClr val="tx1"/>
+                </a:solidFill>
+              </a:rPr>
+              <a:t>(pw)</a:t>
+            </a:r>
+            <a:endParaRPr lang="ko-KR" altLang="en-US" sz="1200">
+              <a:solidFill>
+                <a:schemeClr val="tx1"/>
+              </a:solidFill>
+            </a:endParaRPr>
+          </a:p>
+        </p:txBody>
+      </p:sp>
+      <p:sp>
+        <p:nvSpPr>
+          <p:cNvPr id="29" name="직사각형 28"/>
+          <p:cNvSpPr/>
+          <p:nvPr/>
+        </p:nvSpPr>
+        <p:spPr>
+          <a:xfrm>
+            <a:off x="4067944" y="4365104"/>
+            <a:ext cx="914400" cy="360040"/>
+          </a:xfrm>
+          <a:prstGeom prst="rect">
+            <a:avLst/>
+          </a:prstGeom>
+        </p:spPr>
+        <p:style>
+          <a:lnRef idx="2">
+            <a:schemeClr val="accent1">
+              <a:shade val="50000"/>
+            </a:schemeClr>
+          </a:lnRef>
+          <a:fillRef idx="1">
+            <a:schemeClr val="accent1"/>
+          </a:fillRef>
+          <a:effectRef idx="0">
+            <a:schemeClr val="accent1"/>
+          </a:effectRef>
+          <a:fontRef idx="minor">
+            <a:schemeClr val="lt1"/>
+          </a:fontRef>
+        </p:style>
+        <p:txBody>
+          <a:bodyPr rtlCol="0" anchor="ctr"/>
+          <a:lstStyle/>
+          <a:p>
+            <a:pPr algn="ctr"/>
+            <a:r>
+              <a:rPr lang="ko-KR" altLang="en-US" sz="1200" smtClean="0"/>
+              <a:t>로그인</a:t>
+            </a:r>
+            <a:endParaRPr lang="ko-KR" altLang="en-US" sz="1200"/>
+          </a:p>
+        </p:txBody>
+      </p:sp>
+      <p:sp>
+        <p:nvSpPr>
+          <p:cNvPr id="30" name="직사각형 29"/>
+          <p:cNvSpPr/>
+          <p:nvPr/>
+        </p:nvSpPr>
+        <p:spPr>
+          <a:xfrm>
+            <a:off x="3563888" y="2276872"/>
+            <a:ext cx="1008112" cy="360040"/>
+          </a:xfrm>
+          <a:prstGeom prst="rect">
+            <a:avLst/>
+          </a:prstGeom>
+          <a:noFill/>
+          <a:ln>
+            <a:noFill/>
+          </a:ln>
+        </p:spPr>
+        <p:style>
+          <a:lnRef idx="2">
+            <a:schemeClr val="accent1">
+              <a:shade val="50000"/>
+            </a:schemeClr>
+          </a:lnRef>
+          <a:fillRef idx="1">
+            <a:schemeClr val="accent1"/>
+          </a:fillRef>
+          <a:effectRef idx="0">
+            <a:schemeClr val="accent1"/>
+          </a:effectRef>
+          <a:fontRef idx="minor">
+            <a:schemeClr val="lt1"/>
+          </a:fontRef>
+        </p:style>
+        <p:txBody>
+          <a:bodyPr rtlCol="0" anchor="ctr"/>
+          <a:lstStyle/>
+          <a:p>
+            <a:r>
+              <a:rPr lang="ko-KR" altLang="en-US" sz="1200" smtClean="0">
+                <a:solidFill>
+                  <a:schemeClr val="tx1"/>
+                </a:solidFill>
+              </a:rPr>
+              <a:t>로그인하기</a:t>
+            </a:r>
+            <a:endParaRPr lang="ko-KR" altLang="en-US" sz="1200">
+              <a:solidFill>
+                <a:schemeClr val="tx1"/>
+              </a:solidFill>
+            </a:endParaRPr>
+          </a:p>
+        </p:txBody>
+      </p:sp>
+      <p:sp>
+        <p:nvSpPr>
+          <p:cNvPr id="31" name="TextBox 30"/>
+          <p:cNvSpPr txBox="1"/>
+          <p:nvPr/>
+        </p:nvSpPr>
+        <p:spPr>
+          <a:xfrm>
+            <a:off x="179512" y="5877272"/>
+            <a:ext cx="2650084" cy="276999"/>
+          </a:xfrm>
+          <a:prstGeom prst="rect">
+            <a:avLst/>
+          </a:prstGeom>
+          <a:noFill/>
+        </p:spPr>
+        <p:txBody>
+          <a:bodyPr wrap="none" rtlCol="0">
+            <a:spAutoFit/>
+          </a:bodyPr>
+          <a:lstStyle/>
+          <a:p>
+            <a:r>
+              <a:rPr lang="en-US" altLang="ko-KR" sz="1200" smtClean="0">
+                <a:solidFill>
+                  <a:srgbClr val="C00000"/>
+                </a:solidFill>
+              </a:rPr>
+              <a:t>(</a:t>
+            </a:r>
+            <a:r>
+              <a:rPr lang="ko-KR" altLang="en-US" sz="1200" smtClean="0">
+                <a:solidFill>
+                  <a:srgbClr val="C00000"/>
+                </a:solidFill>
+              </a:rPr>
+              <a:t>게스트 프로필 영역을 클릭한 경우</a:t>
+            </a:r>
+            <a:r>
+              <a:rPr lang="en-US" altLang="ko-KR" sz="1200" smtClean="0">
+                <a:solidFill>
+                  <a:srgbClr val="C00000"/>
+                </a:solidFill>
+              </a:rPr>
+              <a:t>)</a:t>
+            </a:r>
+            <a:endParaRPr lang="ko-KR" altLang="en-US" sz="1200">
+              <a:solidFill>
+                <a:srgbClr val="C00000"/>
+              </a:solidFill>
+            </a:endParaRPr>
           </a:p>
         </p:txBody>
       </p:sp>
@@ -5179,14 +5726,14 @@
       </p:sp>
       <p:sp>
         <p:nvSpPr>
-          <p:cNvPr id="7" name="TextBox 6"/>
+          <p:cNvPr id="9" name="TextBox 8"/>
           <p:cNvSpPr txBox="1"/>
           <p:nvPr/>
         </p:nvSpPr>
         <p:spPr>
           <a:xfrm>
-            <a:off x="107504" y="971436"/>
-            <a:ext cx="646331" cy="369332"/>
+            <a:off x="2627784" y="404664"/>
+            <a:ext cx="1005403" cy="400110"/>
           </a:xfrm>
           <a:prstGeom prst="rect">
             <a:avLst/>
@@ -5200,23 +5747,27 @@
           <a:lstStyle/>
           <a:p>
             <a:r>
-              <a:rPr lang="ko-KR" altLang="en-US" smtClean="0"/>
-              <a:t>일기</a:t>
-            </a:r>
-            <a:endParaRPr lang="ko-KR" altLang="en-US"/>
-          </a:p>
-        </p:txBody>
-      </p:sp>
-      <p:sp>
-        <p:nvSpPr>
-          <p:cNvPr id="8" name="TextBox 7"/>
+              <a:rPr lang="en-US" altLang="ko-KR" sz="2000" smtClean="0"/>
+              <a:t>2026</a:t>
+            </a:r>
+            <a:r>
+              <a:rPr lang="ko-KR" altLang="en-US" sz="2000" smtClean="0"/>
+              <a:t>년</a:t>
+            </a:r>
+            <a:endParaRPr lang="ko-KR" altLang="en-US" sz="2000"/>
+          </a:p>
+        </p:txBody>
+      </p:sp>
+      <p:sp>
+        <p:nvSpPr>
+          <p:cNvPr id="14" name="TextBox 13"/>
           <p:cNvSpPr txBox="1"/>
           <p:nvPr/>
         </p:nvSpPr>
         <p:spPr>
           <a:xfrm>
-            <a:off x="179512" y="1403484"/>
-            <a:ext cx="415498" cy="369332"/>
+            <a:off x="2771800" y="836712"/>
+            <a:ext cx="542136" cy="369332"/>
           </a:xfrm>
           <a:prstGeom prst="rect">
             <a:avLst/>
@@ -5230,23 +5781,27 @@
           <a:lstStyle/>
           <a:p>
             <a:r>
-              <a:rPr lang="ko-KR" altLang="en-US" b="1" smtClean="0"/>
-              <a:t>글</a:t>
-            </a:r>
-            <a:endParaRPr lang="ko-KR" altLang="en-US" b="1"/>
-          </a:p>
-        </p:txBody>
-      </p:sp>
-      <p:sp>
-        <p:nvSpPr>
-          <p:cNvPr id="9" name="TextBox 8"/>
+              <a:rPr lang="en-US" altLang="ko-KR" smtClean="0"/>
+              <a:t>2</a:t>
+            </a:r>
+            <a:r>
+              <a:rPr lang="ko-KR" altLang="en-US" smtClean="0"/>
+              <a:t>월</a:t>
+            </a:r>
+            <a:endParaRPr lang="ko-KR" altLang="en-US"/>
+          </a:p>
+        </p:txBody>
+      </p:sp>
+      <p:sp>
+        <p:nvSpPr>
+          <p:cNvPr id="16" name="TextBox 15"/>
           <p:cNvSpPr txBox="1"/>
           <p:nvPr/>
         </p:nvSpPr>
         <p:spPr>
           <a:xfrm>
-            <a:off x="2627784" y="404664"/>
-            <a:ext cx="697627" cy="400110"/>
+            <a:off x="3059832" y="1268760"/>
+            <a:ext cx="617477" cy="338554"/>
           </a:xfrm>
           <a:prstGeom prst="rect">
             <a:avLst/>
@@ -5260,23 +5815,27 @@
           <a:lstStyle/>
           <a:p>
             <a:r>
-              <a:rPr lang="ko-KR" altLang="en-US" sz="2000" smtClean="0"/>
-              <a:t>제목</a:t>
-            </a:r>
-            <a:endParaRPr lang="ko-KR" altLang="en-US" sz="2000"/>
-          </a:p>
-        </p:txBody>
-      </p:sp>
-      <p:sp>
-        <p:nvSpPr>
-          <p:cNvPr id="10" name="TextBox 9"/>
+              <a:rPr lang="en-US" altLang="ko-KR" sz="1600" smtClean="0"/>
+              <a:t>15</a:t>
+            </a:r>
+            <a:r>
+              <a:rPr lang="ko-KR" altLang="en-US" sz="1600" smtClean="0"/>
+              <a:t>일</a:t>
+            </a:r>
+            <a:endParaRPr lang="ko-KR" altLang="en-US" sz="1600"/>
+          </a:p>
+        </p:txBody>
+      </p:sp>
+      <p:sp>
+        <p:nvSpPr>
+          <p:cNvPr id="17" name="TextBox 16"/>
           <p:cNvSpPr txBox="1"/>
           <p:nvPr/>
         </p:nvSpPr>
         <p:spPr>
           <a:xfrm>
-            <a:off x="2843808" y="836712"/>
-            <a:ext cx="646331" cy="369332"/>
+            <a:off x="3275856" y="1700808"/>
+            <a:ext cx="2518638" cy="307777"/>
           </a:xfrm>
           <a:prstGeom prst="rect">
             <a:avLst/>
@@ -5290,10 +5849,18 @@
           <a:lstStyle/>
           <a:p>
             <a:r>
-              <a:rPr lang="ko-KR" altLang="en-US" smtClean="0"/>
-              <a:t>내용</a:t>
-            </a:r>
-            <a:endParaRPr lang="ko-KR" altLang="en-US"/>
+              <a:rPr lang="en-US" altLang="ko-KR" sz="1400" smtClean="0"/>
+              <a:t>(</a:t>
+            </a:r>
+            <a:r>
+              <a:rPr lang="ko-KR" altLang="en-US" sz="1400" smtClean="0"/>
+              <a:t>가장 빠른 날짜의 일기 내용</a:t>
+            </a:r>
+            <a:r>
+              <a:rPr lang="en-US" altLang="ko-KR" sz="1400" smtClean="0"/>
+              <a:t>)</a:t>
+            </a:r>
+            <a:endParaRPr lang="ko-KR" altLang="en-US" sz="1400"/>
           </a:p>
         </p:txBody>
       </p:sp>
@@ -5440,33 +6007,6 @@
           <a:p>
             <a:endParaRPr lang="en-US" altLang="ko-KR" smtClean="0"/>
           </a:p>
-          <a:p>
-            <a:r>
-              <a:rPr lang="ko-KR" altLang="en-US" smtClean="0"/>
-              <a:t>독후감</a:t>
-            </a:r>
-            <a:endParaRPr lang="en-US" altLang="ko-KR" smtClean="0"/>
-          </a:p>
-          <a:p>
-            <a:endParaRPr lang="en-US" altLang="ko-KR" smtClean="0"/>
-          </a:p>
-          <a:p>
-            <a:r>
-              <a:rPr lang="ko-KR" altLang="en-US" smtClean="0"/>
-              <a:t>시승기</a:t>
-            </a:r>
-            <a:endParaRPr lang="en-US" altLang="ko-KR" smtClean="0"/>
-          </a:p>
-          <a:p>
-            <a:endParaRPr lang="en-US" altLang="ko-KR" smtClean="0"/>
-          </a:p>
-          <a:p>
-            <a:r>
-              <a:rPr lang="ko-KR" altLang="en-US" smtClean="0"/>
-              <a:t>기타</a:t>
-            </a:r>
-            <a:endParaRPr lang="en-US" altLang="ko-KR" smtClean="0"/>
-          </a:p>
         </p:txBody>
       </p:sp>
       <p:sp>
@@ -5525,14 +6065,14 @@
       </p:sp>
       <p:sp>
         <p:nvSpPr>
-          <p:cNvPr id="23" name="TextBox 22"/>
+          <p:cNvPr id="22" name="TextBox 21"/>
           <p:cNvSpPr txBox="1"/>
           <p:nvPr/>
         </p:nvSpPr>
         <p:spPr>
           <a:xfrm>
-            <a:off x="179512" y="611396"/>
-            <a:ext cx="415498" cy="369332"/>
+            <a:off x="107504" y="971436"/>
+            <a:ext cx="646331" cy="369332"/>
           </a:xfrm>
           <a:prstGeom prst="rect">
             <a:avLst/>
@@ -5546,9 +6086,2800 @@
           <a:lstStyle/>
           <a:p>
             <a:r>
+              <a:rPr lang="ko-KR" altLang="en-US" smtClean="0"/>
+              <a:t>일기</a:t>
+            </a:r>
+            <a:endParaRPr lang="ko-KR" altLang="en-US"/>
+          </a:p>
+        </p:txBody>
+      </p:sp>
+      <p:sp>
+        <p:nvSpPr>
+          <p:cNvPr id="23" name="TextBox 22"/>
+          <p:cNvSpPr txBox="1"/>
+          <p:nvPr/>
+        </p:nvSpPr>
+        <p:spPr>
+          <a:xfrm>
+            <a:off x="179512" y="1403484"/>
+            <a:ext cx="415498" cy="369332"/>
+          </a:xfrm>
+          <a:prstGeom prst="rect">
+            <a:avLst/>
+          </a:prstGeom>
+          <a:noFill/>
+        </p:spPr>
+        <p:txBody>
+          <a:bodyPr wrap="none" rtlCol="0">
+            <a:spAutoFit/>
+          </a:bodyPr>
+          <a:lstStyle/>
+          <a:p>
+            <a:r>
+              <a:rPr lang="ko-KR" altLang="en-US" smtClean="0"/>
+              <a:t>글</a:t>
+            </a:r>
+            <a:endParaRPr lang="ko-KR" altLang="en-US"/>
+          </a:p>
+        </p:txBody>
+      </p:sp>
+      <p:sp>
+        <p:nvSpPr>
+          <p:cNvPr id="24" name="TextBox 23"/>
+          <p:cNvSpPr txBox="1"/>
+          <p:nvPr/>
+        </p:nvSpPr>
+        <p:spPr>
+          <a:xfrm>
+            <a:off x="179512" y="611396"/>
+            <a:ext cx="415498" cy="369332"/>
+          </a:xfrm>
+          <a:prstGeom prst="rect">
+            <a:avLst/>
+          </a:prstGeom>
+          <a:noFill/>
+        </p:spPr>
+        <p:txBody>
+          <a:bodyPr wrap="none" rtlCol="0">
+            <a:spAutoFit/>
+          </a:bodyPr>
+          <a:lstStyle/>
+          <a:p>
+            <a:r>
+              <a:rPr lang="ko-KR" altLang="en-US" b="1"/>
+              <a:t>홈</a:t>
+            </a:r>
+          </a:p>
+        </p:txBody>
+      </p:sp>
+      <p:sp>
+        <p:nvSpPr>
+          <p:cNvPr id="25" name="타원 24"/>
+          <p:cNvSpPr/>
+          <p:nvPr/>
+        </p:nvSpPr>
+        <p:spPr>
+          <a:xfrm>
+            <a:off x="7164288" y="6021288"/>
+            <a:ext cx="360040" cy="360040"/>
+          </a:xfrm>
+          <a:prstGeom prst="ellipse">
+            <a:avLst/>
+          </a:prstGeom>
+          <a:effectLst>
+            <a:outerShdw blurRad="50800" dist="38100" dir="2700000" algn="tl" rotWithShape="0">
+              <a:prstClr val="black">
+                <a:alpha val="40000"/>
+              </a:prstClr>
+            </a:outerShdw>
+          </a:effectLst>
+        </p:spPr>
+        <p:style>
+          <a:lnRef idx="2">
+            <a:schemeClr val="accent3"/>
+          </a:lnRef>
+          <a:fillRef idx="1">
+            <a:schemeClr val="lt1"/>
+          </a:fillRef>
+          <a:effectRef idx="0">
+            <a:schemeClr val="accent3"/>
+          </a:effectRef>
+          <a:fontRef idx="minor">
+            <a:schemeClr val="dk1"/>
+          </a:fontRef>
+        </p:style>
+        <p:txBody>
+          <a:bodyPr rtlCol="0" anchor="ctr"/>
+          <a:lstStyle/>
+          <a:p>
+            <a:pPr algn="ctr"/>
+            <a:r>
+              <a:rPr lang="en-US" altLang="ko-KR" smtClean="0"/>
+              <a:t>+</a:t>
+            </a:r>
+            <a:endParaRPr lang="ko-KR" altLang="en-US"/>
+          </a:p>
+        </p:txBody>
+      </p:sp>
+      <p:sp>
+        <p:nvSpPr>
+          <p:cNvPr id="26" name="TextBox 25"/>
+          <p:cNvSpPr txBox="1"/>
+          <p:nvPr/>
+        </p:nvSpPr>
+        <p:spPr>
+          <a:xfrm>
+            <a:off x="467544" y="5877272"/>
+            <a:ext cx="3406702" cy="276999"/>
+          </a:xfrm>
+          <a:prstGeom prst="rect">
+            <a:avLst/>
+          </a:prstGeom>
+          <a:noFill/>
+        </p:spPr>
+        <p:txBody>
+          <a:bodyPr wrap="none" rtlCol="0">
+            <a:spAutoFit/>
+          </a:bodyPr>
+          <a:lstStyle/>
+          <a:p>
+            <a:r>
+              <a:rPr lang="en-US" altLang="ko-KR" sz="1200" smtClean="0">
+                <a:solidFill>
+                  <a:srgbClr val="C00000"/>
+                </a:solidFill>
+              </a:rPr>
+              <a:t>(</a:t>
+            </a:r>
+            <a:r>
+              <a:rPr lang="ko-KR" altLang="en-US" sz="1200" smtClean="0">
+                <a:solidFill>
+                  <a:srgbClr val="C00000"/>
+                </a:solidFill>
+              </a:rPr>
+              <a:t>로그인 했을 때 사용자 이름 또는 </a:t>
+            </a:r>
+            <a:r>
+              <a:rPr lang="en-US" altLang="ko-KR" sz="1200" smtClean="0">
+                <a:solidFill>
+                  <a:srgbClr val="C00000"/>
+                </a:solidFill>
+              </a:rPr>
+              <a:t>id</a:t>
+            </a:r>
+            <a:r>
+              <a:rPr lang="ko-KR" altLang="en-US" sz="1200" smtClean="0">
+                <a:solidFill>
+                  <a:srgbClr val="C00000"/>
+                </a:solidFill>
+              </a:rPr>
+              <a:t>가 나타남</a:t>
+            </a:r>
+            <a:r>
+              <a:rPr lang="en-US" altLang="ko-KR" sz="1200" smtClean="0">
+                <a:solidFill>
+                  <a:srgbClr val="C00000"/>
+                </a:solidFill>
+              </a:rPr>
+              <a:t>)</a:t>
+            </a:r>
+            <a:endParaRPr lang="ko-KR" altLang="en-US" sz="1200">
+              <a:solidFill>
+                <a:srgbClr val="C00000"/>
+              </a:solidFill>
+            </a:endParaRPr>
+          </a:p>
+        </p:txBody>
+      </p:sp>
+    </p:spTree>
+  </p:cSld>
+  <p:clrMapOvr>
+    <a:masterClrMapping/>
+  </p:clrMapOvr>
+</p:sld>
+</file>
+
+<file path=ppt/slides/slide4.xml><?xml version="1.0" encoding="utf-8"?>
+<p:sld xmlns:a="http://schemas.openxmlformats.org/drawingml/2006/main" xmlns:r="http://schemas.openxmlformats.org/officeDocument/2006/relationships" xmlns:p="http://schemas.openxmlformats.org/presentationml/2006/main">
+  <p:cSld>
+    <p:spTree>
+      <p:nvGrpSpPr>
+        <p:cNvPr id="1" name=""/>
+        <p:cNvGrpSpPr/>
+        <p:nvPr/>
+      </p:nvGrpSpPr>
+      <p:grpSpPr>
+        <a:xfrm>
+          <a:off x="0" y="0"/>
+          <a:ext cx="0" cy="0"/>
+          <a:chOff x="0" y="0"/>
+          <a:chExt cx="0" cy="0"/>
+        </a:xfrm>
+      </p:grpSpPr>
+      <p:sp>
+        <p:nvSpPr>
+          <p:cNvPr id="4" name="직사각형 3"/>
+          <p:cNvSpPr/>
+          <p:nvPr/>
+        </p:nvSpPr>
+        <p:spPr>
+          <a:xfrm>
+            <a:off x="0" y="0"/>
+            <a:ext cx="2411760" cy="6858000"/>
+          </a:xfrm>
+          <a:prstGeom prst="rect">
+            <a:avLst/>
+          </a:prstGeom>
+        </p:spPr>
+        <p:style>
+          <a:lnRef idx="2">
+            <a:schemeClr val="accent6"/>
+          </a:lnRef>
+          <a:fillRef idx="1">
+            <a:schemeClr val="lt1"/>
+          </a:fillRef>
+          <a:effectRef idx="0">
+            <a:schemeClr val="accent6"/>
+          </a:effectRef>
+          <a:fontRef idx="minor">
+            <a:schemeClr val="dk1"/>
+          </a:fontRef>
+        </p:style>
+        <p:txBody>
+          <a:bodyPr rtlCol="0" anchor="ctr"/>
+          <a:lstStyle/>
+          <a:p>
+            <a:pPr algn="ctr"/>
+            <a:endParaRPr lang="ko-KR" altLang="en-US"/>
+          </a:p>
+        </p:txBody>
+      </p:sp>
+      <p:sp>
+        <p:nvSpPr>
+          <p:cNvPr id="5" name="타원 4"/>
+          <p:cNvSpPr/>
+          <p:nvPr/>
+        </p:nvSpPr>
+        <p:spPr>
+          <a:xfrm>
+            <a:off x="179512" y="6165304"/>
+            <a:ext cx="504056" cy="504056"/>
+          </a:xfrm>
+          <a:prstGeom prst="ellipse">
+            <a:avLst/>
+          </a:prstGeom>
+        </p:spPr>
+        <p:style>
+          <a:lnRef idx="2">
+            <a:schemeClr val="accent1">
+              <a:shade val="50000"/>
+            </a:schemeClr>
+          </a:lnRef>
+          <a:fillRef idx="1">
+            <a:schemeClr val="accent1"/>
+          </a:fillRef>
+          <a:effectRef idx="0">
+            <a:schemeClr val="accent1"/>
+          </a:effectRef>
+          <a:fontRef idx="minor">
+            <a:schemeClr val="lt1"/>
+          </a:fontRef>
+        </p:style>
+        <p:txBody>
+          <a:bodyPr rtlCol="0" anchor="ctr"/>
+          <a:lstStyle/>
+          <a:p>
+            <a:pPr algn="ctr"/>
+            <a:endParaRPr lang="ko-KR" altLang="en-US"/>
+          </a:p>
+        </p:txBody>
+      </p:sp>
+      <p:sp>
+        <p:nvSpPr>
+          <p:cNvPr id="6" name="TextBox 5"/>
+          <p:cNvSpPr txBox="1"/>
+          <p:nvPr/>
+        </p:nvSpPr>
+        <p:spPr>
+          <a:xfrm>
+            <a:off x="755576" y="6237312"/>
+            <a:ext cx="877163" cy="369332"/>
+          </a:xfrm>
+          <a:prstGeom prst="rect">
+            <a:avLst/>
+          </a:prstGeom>
+          <a:noFill/>
+        </p:spPr>
+        <p:txBody>
+          <a:bodyPr wrap="none" rtlCol="0">
+            <a:spAutoFit/>
+          </a:bodyPr>
+          <a:lstStyle/>
+          <a:p>
+            <a:r>
+              <a:rPr lang="ko-KR" altLang="en-US" smtClean="0"/>
+              <a:t>이민혁</a:t>
+            </a:r>
+            <a:endParaRPr lang="ko-KR" altLang="en-US"/>
+          </a:p>
+        </p:txBody>
+      </p:sp>
+      <p:sp>
+        <p:nvSpPr>
+          <p:cNvPr id="9" name="TextBox 8"/>
+          <p:cNvSpPr txBox="1"/>
+          <p:nvPr/>
+        </p:nvSpPr>
+        <p:spPr>
+          <a:xfrm>
+            <a:off x="2627784" y="404664"/>
+            <a:ext cx="1005403" cy="400110"/>
+          </a:xfrm>
+          <a:prstGeom prst="rect">
+            <a:avLst/>
+          </a:prstGeom>
+          <a:noFill/>
+        </p:spPr>
+        <p:txBody>
+          <a:bodyPr wrap="none" rtlCol="0">
+            <a:spAutoFit/>
+          </a:bodyPr>
+          <a:lstStyle/>
+          <a:p>
+            <a:r>
+              <a:rPr lang="en-US" altLang="ko-KR" sz="2000" smtClean="0"/>
+              <a:t>2026</a:t>
+            </a:r>
+            <a:r>
+              <a:rPr lang="ko-KR" altLang="en-US" sz="2000" smtClean="0"/>
+              <a:t>년</a:t>
+            </a:r>
+            <a:endParaRPr lang="ko-KR" altLang="en-US" sz="2000"/>
+          </a:p>
+        </p:txBody>
+      </p:sp>
+      <p:sp>
+        <p:nvSpPr>
+          <p:cNvPr id="14" name="TextBox 13"/>
+          <p:cNvSpPr txBox="1"/>
+          <p:nvPr/>
+        </p:nvSpPr>
+        <p:spPr>
+          <a:xfrm>
+            <a:off x="2771800" y="836712"/>
+            <a:ext cx="542136" cy="369332"/>
+          </a:xfrm>
+          <a:prstGeom prst="rect">
+            <a:avLst/>
+          </a:prstGeom>
+          <a:noFill/>
+        </p:spPr>
+        <p:txBody>
+          <a:bodyPr wrap="none" rtlCol="0">
+            <a:spAutoFit/>
+          </a:bodyPr>
+          <a:lstStyle/>
+          <a:p>
+            <a:r>
+              <a:rPr lang="en-US" altLang="ko-KR" smtClean="0"/>
+              <a:t>2</a:t>
+            </a:r>
+            <a:r>
+              <a:rPr lang="ko-KR" altLang="en-US" smtClean="0"/>
+              <a:t>월</a:t>
+            </a:r>
+            <a:endParaRPr lang="ko-KR" altLang="en-US"/>
+          </a:p>
+        </p:txBody>
+      </p:sp>
+      <p:sp>
+        <p:nvSpPr>
+          <p:cNvPr id="16" name="TextBox 15"/>
+          <p:cNvSpPr txBox="1"/>
+          <p:nvPr/>
+        </p:nvSpPr>
+        <p:spPr>
+          <a:xfrm>
+            <a:off x="3059832" y="1268760"/>
+            <a:ext cx="617477" cy="338554"/>
+          </a:xfrm>
+          <a:prstGeom prst="rect">
+            <a:avLst/>
+          </a:prstGeom>
+          <a:noFill/>
+        </p:spPr>
+        <p:txBody>
+          <a:bodyPr wrap="none" rtlCol="0">
+            <a:spAutoFit/>
+          </a:bodyPr>
+          <a:lstStyle/>
+          <a:p>
+            <a:r>
+              <a:rPr lang="en-US" altLang="ko-KR" sz="1600" smtClean="0"/>
+              <a:t>15</a:t>
+            </a:r>
+            <a:r>
+              <a:rPr lang="ko-KR" altLang="en-US" sz="1600" smtClean="0"/>
+              <a:t>일</a:t>
+            </a:r>
+            <a:endParaRPr lang="ko-KR" altLang="en-US" sz="1600"/>
+          </a:p>
+        </p:txBody>
+      </p:sp>
+      <p:sp>
+        <p:nvSpPr>
+          <p:cNvPr id="17" name="TextBox 16"/>
+          <p:cNvSpPr txBox="1"/>
+          <p:nvPr/>
+        </p:nvSpPr>
+        <p:spPr>
+          <a:xfrm>
+            <a:off x="3275856" y="1700808"/>
+            <a:ext cx="2518638" cy="307777"/>
+          </a:xfrm>
+          <a:prstGeom prst="rect">
+            <a:avLst/>
+          </a:prstGeom>
+          <a:noFill/>
+        </p:spPr>
+        <p:txBody>
+          <a:bodyPr wrap="none" rtlCol="0">
+            <a:spAutoFit/>
+          </a:bodyPr>
+          <a:lstStyle/>
+          <a:p>
+            <a:r>
+              <a:rPr lang="en-US" altLang="ko-KR" sz="1400" smtClean="0"/>
+              <a:t>(</a:t>
+            </a:r>
+            <a:r>
+              <a:rPr lang="ko-KR" altLang="en-US" sz="1400" smtClean="0"/>
+              <a:t>가장 빠른 날짜의 일기 내용</a:t>
+            </a:r>
+            <a:r>
+              <a:rPr lang="en-US" altLang="ko-KR" sz="1400" smtClean="0"/>
+              <a:t>)</a:t>
+            </a:r>
+            <a:endParaRPr lang="ko-KR" altLang="en-US" sz="1400"/>
+          </a:p>
+        </p:txBody>
+      </p:sp>
+      <p:sp>
+        <p:nvSpPr>
+          <p:cNvPr id="18" name="TextBox 17"/>
+          <p:cNvSpPr txBox="1"/>
+          <p:nvPr/>
+        </p:nvSpPr>
+        <p:spPr>
+          <a:xfrm>
+            <a:off x="6012160" y="6550223"/>
+            <a:ext cx="1612942" cy="307777"/>
+          </a:xfrm>
+          <a:prstGeom prst="rect">
+            <a:avLst/>
+          </a:prstGeom>
+          <a:noFill/>
+        </p:spPr>
+        <p:txBody>
+          <a:bodyPr wrap="none" rtlCol="0">
+            <a:spAutoFit/>
+          </a:bodyPr>
+          <a:lstStyle/>
+          <a:p>
+            <a:r>
+              <a:rPr lang="en-US" altLang="ko-KR" sz="1400" smtClean="0">
+                <a:solidFill>
+                  <a:srgbClr val="FF0000"/>
+                </a:solidFill>
+              </a:rPr>
+              <a:t>(</a:t>
+            </a:r>
+            <a:r>
+              <a:rPr lang="ko-KR" altLang="en-US" sz="1400" smtClean="0">
+                <a:solidFill>
+                  <a:srgbClr val="FF0000"/>
+                </a:solidFill>
+              </a:rPr>
+              <a:t>마크다운 컨텐츠</a:t>
+            </a:r>
+            <a:r>
+              <a:rPr lang="en-US" altLang="ko-KR" sz="1400" smtClean="0">
+                <a:solidFill>
+                  <a:srgbClr val="FF0000"/>
+                </a:solidFill>
+              </a:rPr>
+              <a:t>)</a:t>
+            </a:r>
+            <a:endParaRPr lang="ko-KR" altLang="en-US" sz="1400">
+              <a:solidFill>
+                <a:srgbClr val="FF0000"/>
+              </a:solidFill>
+            </a:endParaRPr>
+          </a:p>
+        </p:txBody>
+      </p:sp>
+      <p:sp>
+        <p:nvSpPr>
+          <p:cNvPr id="19" name="TextBox 18"/>
+          <p:cNvSpPr txBox="1"/>
+          <p:nvPr/>
+        </p:nvSpPr>
+        <p:spPr>
+          <a:xfrm>
+            <a:off x="1475656" y="6550223"/>
+            <a:ext cx="1011815" cy="307777"/>
+          </a:xfrm>
+          <a:prstGeom prst="rect">
+            <a:avLst/>
+          </a:prstGeom>
+          <a:noFill/>
+        </p:spPr>
+        <p:txBody>
+          <a:bodyPr wrap="none" rtlCol="0">
+            <a:spAutoFit/>
+          </a:bodyPr>
+          <a:lstStyle/>
+          <a:p>
+            <a:r>
+              <a:rPr lang="en-US" altLang="ko-KR" sz="1400" smtClean="0">
+                <a:solidFill>
+                  <a:srgbClr val="FF0000"/>
+                </a:solidFill>
+              </a:rPr>
+              <a:t>(</a:t>
+            </a:r>
+            <a:r>
+              <a:rPr lang="ko-KR" altLang="en-US" sz="1400" smtClean="0">
+                <a:solidFill>
+                  <a:srgbClr val="FF0000"/>
+                </a:solidFill>
+              </a:rPr>
+              <a:t>사이드바</a:t>
+            </a:r>
+            <a:r>
+              <a:rPr lang="en-US" altLang="ko-KR" sz="1400" smtClean="0">
+                <a:solidFill>
+                  <a:srgbClr val="FF0000"/>
+                </a:solidFill>
+              </a:rPr>
+              <a:t>)</a:t>
+            </a:r>
+            <a:endParaRPr lang="ko-KR" altLang="en-US" sz="1400">
+              <a:solidFill>
+                <a:srgbClr val="FF0000"/>
+              </a:solidFill>
+            </a:endParaRPr>
+          </a:p>
+        </p:txBody>
+      </p:sp>
+      <p:sp>
+        <p:nvSpPr>
+          <p:cNvPr id="20" name="직사각형 19"/>
+          <p:cNvSpPr/>
+          <p:nvPr/>
+        </p:nvSpPr>
+        <p:spPr>
+          <a:xfrm>
+            <a:off x="7668344" y="0"/>
+            <a:ext cx="1475656" cy="6858000"/>
+          </a:xfrm>
+          <a:prstGeom prst="rect">
+            <a:avLst/>
+          </a:prstGeom>
+        </p:spPr>
+        <p:style>
+          <a:lnRef idx="2">
+            <a:schemeClr val="accent6"/>
+          </a:lnRef>
+          <a:fillRef idx="1">
+            <a:schemeClr val="lt1"/>
+          </a:fillRef>
+          <a:effectRef idx="0">
+            <a:schemeClr val="accent6"/>
+          </a:effectRef>
+          <a:fontRef idx="minor">
+            <a:schemeClr val="dk1"/>
+          </a:fontRef>
+        </p:style>
+        <p:txBody>
+          <a:bodyPr rtlCol="0" anchor="t" anchorCtr="0"/>
+          <a:lstStyle/>
+          <a:p>
+            <a:endParaRPr lang="en-US" altLang="ko-KR" smtClean="0"/>
+          </a:p>
+        </p:txBody>
+      </p:sp>
+      <p:sp>
+        <p:nvSpPr>
+          <p:cNvPr id="21" name="TextBox 20"/>
+          <p:cNvSpPr txBox="1"/>
+          <p:nvPr/>
+        </p:nvSpPr>
+        <p:spPr>
+          <a:xfrm>
+            <a:off x="7734640" y="6581001"/>
+            <a:ext cx="1409360" cy="276999"/>
+          </a:xfrm>
+          <a:prstGeom prst="rect">
+            <a:avLst/>
+          </a:prstGeom>
+          <a:noFill/>
+        </p:spPr>
+        <p:txBody>
+          <a:bodyPr wrap="none" rtlCol="0">
+            <a:spAutoFit/>
+          </a:bodyPr>
+          <a:lstStyle/>
+          <a:p>
+            <a:r>
+              <a:rPr lang="en-US" altLang="ko-KR" sz="1200" smtClean="0">
+                <a:solidFill>
+                  <a:srgbClr val="FF0000"/>
+                </a:solidFill>
+              </a:rPr>
+              <a:t>(</a:t>
+            </a:r>
+            <a:r>
+              <a:rPr lang="ko-KR" altLang="en-US" sz="1200" smtClean="0">
+                <a:solidFill>
+                  <a:srgbClr val="FF0000"/>
+                </a:solidFill>
+              </a:rPr>
+              <a:t>일기의 연도선택</a:t>
+            </a:r>
+            <a:r>
+              <a:rPr lang="en-US" altLang="ko-KR" sz="1200" smtClean="0">
+                <a:solidFill>
+                  <a:srgbClr val="FF0000"/>
+                </a:solidFill>
+              </a:rPr>
+              <a:t>)</a:t>
+            </a:r>
+            <a:endParaRPr lang="ko-KR" altLang="en-US" sz="1200">
+              <a:solidFill>
+                <a:srgbClr val="FF0000"/>
+              </a:solidFill>
+            </a:endParaRPr>
+          </a:p>
+        </p:txBody>
+      </p:sp>
+      <p:sp>
+        <p:nvSpPr>
+          <p:cNvPr id="22" name="TextBox 21"/>
+          <p:cNvSpPr txBox="1"/>
+          <p:nvPr/>
+        </p:nvSpPr>
+        <p:spPr>
+          <a:xfrm>
+            <a:off x="107504" y="971436"/>
+            <a:ext cx="646331" cy="369332"/>
+          </a:xfrm>
+          <a:prstGeom prst="rect">
+            <a:avLst/>
+          </a:prstGeom>
+          <a:noFill/>
+        </p:spPr>
+        <p:txBody>
+          <a:bodyPr wrap="none" rtlCol="0">
+            <a:spAutoFit/>
+          </a:bodyPr>
+          <a:lstStyle/>
+          <a:p>
+            <a:r>
+              <a:rPr lang="ko-KR" altLang="en-US" smtClean="0"/>
+              <a:t>일기</a:t>
+            </a:r>
+            <a:endParaRPr lang="ko-KR" altLang="en-US"/>
+          </a:p>
+        </p:txBody>
+      </p:sp>
+      <p:sp>
+        <p:nvSpPr>
+          <p:cNvPr id="23" name="TextBox 22"/>
+          <p:cNvSpPr txBox="1"/>
+          <p:nvPr/>
+        </p:nvSpPr>
+        <p:spPr>
+          <a:xfrm>
+            <a:off x="179512" y="1403484"/>
+            <a:ext cx="415498" cy="369332"/>
+          </a:xfrm>
+          <a:prstGeom prst="rect">
+            <a:avLst/>
+          </a:prstGeom>
+          <a:noFill/>
+        </p:spPr>
+        <p:txBody>
+          <a:bodyPr wrap="none" rtlCol="0">
+            <a:spAutoFit/>
+          </a:bodyPr>
+          <a:lstStyle/>
+          <a:p>
+            <a:r>
+              <a:rPr lang="ko-KR" altLang="en-US" smtClean="0"/>
+              <a:t>글</a:t>
+            </a:r>
+            <a:endParaRPr lang="ko-KR" altLang="en-US"/>
+          </a:p>
+        </p:txBody>
+      </p:sp>
+      <p:sp>
+        <p:nvSpPr>
+          <p:cNvPr id="24" name="TextBox 23"/>
+          <p:cNvSpPr txBox="1"/>
+          <p:nvPr/>
+        </p:nvSpPr>
+        <p:spPr>
+          <a:xfrm>
+            <a:off x="179512" y="611396"/>
+            <a:ext cx="415498" cy="369332"/>
+          </a:xfrm>
+          <a:prstGeom prst="rect">
+            <a:avLst/>
+          </a:prstGeom>
+          <a:noFill/>
+        </p:spPr>
+        <p:txBody>
+          <a:bodyPr wrap="none" rtlCol="0">
+            <a:spAutoFit/>
+          </a:bodyPr>
+          <a:lstStyle/>
+          <a:p>
+            <a:r>
+              <a:rPr lang="ko-KR" altLang="en-US" b="1"/>
+              <a:t>홈</a:t>
+            </a:r>
+          </a:p>
+        </p:txBody>
+      </p:sp>
+      <p:sp>
+        <p:nvSpPr>
+          <p:cNvPr id="25" name="타원 24"/>
+          <p:cNvSpPr/>
+          <p:nvPr/>
+        </p:nvSpPr>
+        <p:spPr>
+          <a:xfrm>
+            <a:off x="7164288" y="6021288"/>
+            <a:ext cx="360040" cy="360040"/>
+          </a:xfrm>
+          <a:prstGeom prst="ellipse">
+            <a:avLst/>
+          </a:prstGeom>
+          <a:effectLst>
+            <a:outerShdw blurRad="50800" dist="38100" dir="2700000" algn="tl" rotWithShape="0">
+              <a:prstClr val="black">
+                <a:alpha val="40000"/>
+              </a:prstClr>
+            </a:outerShdw>
+          </a:effectLst>
+        </p:spPr>
+        <p:style>
+          <a:lnRef idx="2">
+            <a:schemeClr val="accent3"/>
+          </a:lnRef>
+          <a:fillRef idx="1">
+            <a:schemeClr val="lt1"/>
+          </a:fillRef>
+          <a:effectRef idx="0">
+            <a:schemeClr val="accent3"/>
+          </a:effectRef>
+          <a:fontRef idx="minor">
+            <a:schemeClr val="dk1"/>
+          </a:fontRef>
+        </p:style>
+        <p:txBody>
+          <a:bodyPr rtlCol="0" anchor="ctr"/>
+          <a:lstStyle/>
+          <a:p>
+            <a:pPr algn="ctr"/>
+            <a:r>
+              <a:rPr lang="en-US" altLang="ko-KR" smtClean="0"/>
+              <a:t>+</a:t>
+            </a:r>
+            <a:endParaRPr lang="ko-KR" altLang="en-US"/>
+          </a:p>
+        </p:txBody>
+      </p:sp>
+      <p:sp>
+        <p:nvSpPr>
+          <p:cNvPr id="26" name="TextBox 25"/>
+          <p:cNvSpPr txBox="1"/>
+          <p:nvPr/>
+        </p:nvSpPr>
+        <p:spPr>
+          <a:xfrm>
+            <a:off x="467544" y="5877272"/>
+            <a:ext cx="3406702" cy="276999"/>
+          </a:xfrm>
+          <a:prstGeom prst="rect">
+            <a:avLst/>
+          </a:prstGeom>
+          <a:noFill/>
+        </p:spPr>
+        <p:txBody>
+          <a:bodyPr wrap="none" rtlCol="0">
+            <a:spAutoFit/>
+          </a:bodyPr>
+          <a:lstStyle/>
+          <a:p>
+            <a:r>
+              <a:rPr lang="en-US" altLang="ko-KR" sz="1200" smtClean="0">
+                <a:solidFill>
+                  <a:srgbClr val="C00000"/>
+                </a:solidFill>
+              </a:rPr>
+              <a:t>(</a:t>
+            </a:r>
+            <a:r>
+              <a:rPr lang="ko-KR" altLang="en-US" sz="1200" smtClean="0">
+                <a:solidFill>
+                  <a:srgbClr val="C00000"/>
+                </a:solidFill>
+              </a:rPr>
+              <a:t>로그인 했을 때 사용자 이름 또는 </a:t>
+            </a:r>
+            <a:r>
+              <a:rPr lang="en-US" altLang="ko-KR" sz="1200" smtClean="0">
+                <a:solidFill>
+                  <a:srgbClr val="C00000"/>
+                </a:solidFill>
+              </a:rPr>
+              <a:t>id</a:t>
+            </a:r>
+            <a:r>
+              <a:rPr lang="ko-KR" altLang="en-US" sz="1200" smtClean="0">
+                <a:solidFill>
+                  <a:srgbClr val="C00000"/>
+                </a:solidFill>
+              </a:rPr>
+              <a:t>가 나타남</a:t>
+            </a:r>
+            <a:r>
+              <a:rPr lang="en-US" altLang="ko-KR" sz="1200" smtClean="0">
+                <a:solidFill>
+                  <a:srgbClr val="C00000"/>
+                </a:solidFill>
+              </a:rPr>
+              <a:t>)</a:t>
+            </a:r>
+            <a:endParaRPr lang="ko-KR" altLang="en-US" sz="1200">
+              <a:solidFill>
+                <a:srgbClr val="C00000"/>
+              </a:solidFill>
+            </a:endParaRPr>
+          </a:p>
+        </p:txBody>
+      </p:sp>
+      <p:sp>
+        <p:nvSpPr>
+          <p:cNvPr id="27" name="직사각형 26"/>
+          <p:cNvSpPr/>
+          <p:nvPr/>
+        </p:nvSpPr>
+        <p:spPr>
+          <a:xfrm>
+            <a:off x="0" y="-315416"/>
+            <a:ext cx="9144000" cy="7173416"/>
+          </a:xfrm>
+          <a:prstGeom prst="rect">
+            <a:avLst/>
+          </a:prstGeom>
+          <a:solidFill>
+            <a:schemeClr val="tx1">
+              <a:alpha val="46000"/>
+            </a:schemeClr>
+          </a:solidFill>
+        </p:spPr>
+        <p:style>
+          <a:lnRef idx="2">
+            <a:schemeClr val="accent1">
+              <a:shade val="50000"/>
+            </a:schemeClr>
+          </a:lnRef>
+          <a:fillRef idx="1">
+            <a:schemeClr val="accent1"/>
+          </a:fillRef>
+          <a:effectRef idx="0">
+            <a:schemeClr val="accent1"/>
+          </a:effectRef>
+          <a:fontRef idx="minor">
+            <a:schemeClr val="lt1"/>
+          </a:fontRef>
+        </p:style>
+        <p:txBody>
+          <a:bodyPr rtlCol="0" anchor="ctr"/>
+          <a:lstStyle/>
+          <a:p>
+            <a:pPr algn="ctr"/>
+            <a:endParaRPr lang="ko-KR" altLang="en-US"/>
+          </a:p>
+        </p:txBody>
+      </p:sp>
+      <p:sp>
+        <p:nvSpPr>
+          <p:cNvPr id="28" name="직사각형 27"/>
+          <p:cNvSpPr/>
+          <p:nvPr/>
+        </p:nvSpPr>
+        <p:spPr>
+          <a:xfrm>
+            <a:off x="1259632" y="692696"/>
+            <a:ext cx="6624736" cy="5256584"/>
+          </a:xfrm>
+          <a:prstGeom prst="rect">
+            <a:avLst/>
+          </a:prstGeom>
+          <a:solidFill>
+            <a:schemeClr val="bg1">
+              <a:lumMod val="85000"/>
+            </a:schemeClr>
+          </a:solidFill>
+        </p:spPr>
+        <p:style>
+          <a:lnRef idx="2">
+            <a:schemeClr val="accent1"/>
+          </a:lnRef>
+          <a:fillRef idx="1">
+            <a:schemeClr val="lt1"/>
+          </a:fillRef>
+          <a:effectRef idx="0">
+            <a:schemeClr val="accent1"/>
+          </a:effectRef>
+          <a:fontRef idx="minor">
+            <a:schemeClr val="dk1"/>
+          </a:fontRef>
+        </p:style>
+        <p:txBody>
+          <a:bodyPr rtlCol="0" anchor="ctr"/>
+          <a:lstStyle/>
+          <a:p>
+            <a:pPr algn="ctr"/>
+            <a:endParaRPr lang="ko-KR" altLang="en-US"/>
+          </a:p>
+        </p:txBody>
+      </p:sp>
+      <p:sp>
+        <p:nvSpPr>
+          <p:cNvPr id="29" name="직사각형 28"/>
+          <p:cNvSpPr/>
+          <p:nvPr/>
+        </p:nvSpPr>
+        <p:spPr>
+          <a:xfrm>
+            <a:off x="1547664" y="1340768"/>
+            <a:ext cx="3384376" cy="360040"/>
+          </a:xfrm>
+          <a:prstGeom prst="rect">
+            <a:avLst/>
+          </a:prstGeom>
+          <a:solidFill>
+            <a:schemeClr val="bg1">
+              <a:lumMod val="95000"/>
+            </a:schemeClr>
+          </a:solidFill>
+        </p:spPr>
+        <p:style>
+          <a:lnRef idx="2">
+            <a:schemeClr val="accent1">
+              <a:shade val="50000"/>
+            </a:schemeClr>
+          </a:lnRef>
+          <a:fillRef idx="1">
+            <a:schemeClr val="accent1"/>
+          </a:fillRef>
+          <a:effectRef idx="0">
+            <a:schemeClr val="accent1"/>
+          </a:effectRef>
+          <a:fontRef idx="minor">
+            <a:schemeClr val="lt1"/>
+          </a:fontRef>
+        </p:style>
+        <p:txBody>
+          <a:bodyPr rtlCol="0" anchor="ctr"/>
+          <a:lstStyle/>
+          <a:p>
+            <a:r>
+              <a:rPr lang="en-US" altLang="ko-KR" sz="1200" smtClean="0">
+                <a:solidFill>
+                  <a:schemeClr val="tx1"/>
+                </a:solidFill>
+              </a:rPr>
+              <a:t>(</a:t>
+            </a:r>
+            <a:r>
+              <a:rPr lang="ko-KR" altLang="en-US" sz="1200" smtClean="0">
+                <a:solidFill>
+                  <a:schemeClr val="tx1"/>
+                </a:solidFill>
+              </a:rPr>
+              <a:t>제목</a:t>
+            </a:r>
+            <a:r>
+              <a:rPr lang="en-US" altLang="ko-KR" sz="1200" smtClean="0">
+                <a:solidFill>
+                  <a:schemeClr val="tx1"/>
+                </a:solidFill>
+              </a:rPr>
+              <a:t> </a:t>
+            </a:r>
+            <a:r>
+              <a:rPr lang="en-US" altLang="ko-KR" sz="1200" smtClean="0">
+                <a:solidFill>
+                  <a:schemeClr val="tx1"/>
+                </a:solidFill>
+              </a:rPr>
+              <a:t>– </a:t>
+            </a:r>
+            <a:r>
+              <a:rPr lang="ko-KR" altLang="en-US" sz="1200" smtClean="0">
+                <a:solidFill>
+                  <a:schemeClr val="tx1"/>
+                </a:solidFill>
+              </a:rPr>
+              <a:t>입력하지 않으면 날짜와 같이 입력</a:t>
+            </a:r>
+            <a:r>
+              <a:rPr lang="en-US" altLang="ko-KR" sz="1200" smtClean="0">
+                <a:solidFill>
+                  <a:schemeClr val="tx1"/>
+                </a:solidFill>
+              </a:rPr>
+              <a:t>)</a:t>
+            </a:r>
+            <a:r>
+              <a:rPr lang="ko-KR" altLang="en-US" sz="1200" smtClean="0">
+                <a:solidFill>
+                  <a:schemeClr val="tx1"/>
+                </a:solidFill>
+              </a:rPr>
+              <a:t> </a:t>
+            </a:r>
+            <a:endParaRPr lang="ko-KR" altLang="en-US" sz="1200">
+              <a:solidFill>
+                <a:schemeClr val="tx1"/>
+              </a:solidFill>
+            </a:endParaRPr>
+          </a:p>
+        </p:txBody>
+      </p:sp>
+      <p:sp>
+        <p:nvSpPr>
+          <p:cNvPr id="30" name="직사각형 29"/>
+          <p:cNvSpPr/>
+          <p:nvPr/>
+        </p:nvSpPr>
+        <p:spPr>
+          <a:xfrm>
+            <a:off x="1547664" y="1844824"/>
+            <a:ext cx="3384376" cy="360040"/>
+          </a:xfrm>
+          <a:prstGeom prst="rect">
+            <a:avLst/>
+          </a:prstGeom>
+          <a:solidFill>
+            <a:schemeClr val="bg1">
+              <a:lumMod val="95000"/>
+            </a:schemeClr>
+          </a:solidFill>
+        </p:spPr>
+        <p:style>
+          <a:lnRef idx="2">
+            <a:schemeClr val="accent1">
+              <a:shade val="50000"/>
+            </a:schemeClr>
+          </a:lnRef>
+          <a:fillRef idx="1">
+            <a:schemeClr val="accent1"/>
+          </a:fillRef>
+          <a:effectRef idx="0">
+            <a:schemeClr val="accent1"/>
+          </a:effectRef>
+          <a:fontRef idx="minor">
+            <a:schemeClr val="lt1"/>
+          </a:fontRef>
+        </p:style>
+        <p:txBody>
+          <a:bodyPr rtlCol="0" anchor="ctr"/>
+          <a:lstStyle/>
+          <a:p>
+            <a:r>
+              <a:rPr lang="en-US" altLang="ko-KR" sz="1200" smtClean="0">
+                <a:solidFill>
+                  <a:schemeClr val="tx1"/>
+                </a:solidFill>
+              </a:rPr>
+              <a:t>(</a:t>
+            </a:r>
+            <a:r>
+              <a:rPr lang="ko-KR" altLang="en-US" sz="1200" smtClean="0">
+                <a:solidFill>
+                  <a:schemeClr val="tx1"/>
+                </a:solidFill>
+              </a:rPr>
+              <a:t>날짜 선택창</a:t>
+            </a:r>
+            <a:r>
+              <a:rPr lang="en-US" altLang="ko-KR" sz="1200" smtClean="0">
+                <a:solidFill>
+                  <a:schemeClr val="tx1"/>
+                </a:solidFill>
+              </a:rPr>
+              <a:t>)</a:t>
+            </a:r>
+            <a:endParaRPr lang="ko-KR" altLang="en-US" sz="1200">
+              <a:solidFill>
+                <a:schemeClr val="tx1"/>
+              </a:solidFill>
+            </a:endParaRPr>
+          </a:p>
+        </p:txBody>
+      </p:sp>
+      <p:sp>
+        <p:nvSpPr>
+          <p:cNvPr id="31" name="직사각형 30"/>
+          <p:cNvSpPr/>
+          <p:nvPr/>
+        </p:nvSpPr>
+        <p:spPr>
+          <a:xfrm>
+            <a:off x="6588224" y="5373216"/>
+            <a:ext cx="914400" cy="360040"/>
+          </a:xfrm>
+          <a:prstGeom prst="rect">
+            <a:avLst/>
+          </a:prstGeom>
+        </p:spPr>
+        <p:style>
+          <a:lnRef idx="2">
+            <a:schemeClr val="accent1">
+              <a:shade val="50000"/>
+            </a:schemeClr>
+          </a:lnRef>
+          <a:fillRef idx="1">
+            <a:schemeClr val="accent1"/>
+          </a:fillRef>
+          <a:effectRef idx="0">
+            <a:schemeClr val="accent1"/>
+          </a:effectRef>
+          <a:fontRef idx="minor">
+            <a:schemeClr val="lt1"/>
+          </a:fontRef>
+        </p:style>
+        <p:txBody>
+          <a:bodyPr rtlCol="0" anchor="ctr"/>
+          <a:lstStyle/>
+          <a:p>
+            <a:pPr algn="ctr"/>
+            <a:r>
+              <a:rPr lang="ko-KR" altLang="en-US" sz="1200" smtClean="0"/>
+              <a:t>입력</a:t>
+            </a:r>
+            <a:endParaRPr lang="ko-KR" altLang="en-US" sz="1200"/>
+          </a:p>
+        </p:txBody>
+      </p:sp>
+      <p:sp>
+        <p:nvSpPr>
+          <p:cNvPr id="32" name="직사각형 31"/>
+          <p:cNvSpPr/>
+          <p:nvPr/>
+        </p:nvSpPr>
+        <p:spPr>
+          <a:xfrm>
+            <a:off x="1475656" y="908720"/>
+            <a:ext cx="1008112" cy="360040"/>
+          </a:xfrm>
+          <a:prstGeom prst="rect">
+            <a:avLst/>
+          </a:prstGeom>
+          <a:noFill/>
+          <a:ln>
+            <a:noFill/>
+          </a:ln>
+        </p:spPr>
+        <p:style>
+          <a:lnRef idx="2">
+            <a:schemeClr val="accent1">
+              <a:shade val="50000"/>
+            </a:schemeClr>
+          </a:lnRef>
+          <a:fillRef idx="1">
+            <a:schemeClr val="accent1"/>
+          </a:fillRef>
+          <a:effectRef idx="0">
+            <a:schemeClr val="accent1"/>
+          </a:effectRef>
+          <a:fontRef idx="minor">
+            <a:schemeClr val="lt1"/>
+          </a:fontRef>
+        </p:style>
+        <p:txBody>
+          <a:bodyPr rtlCol="0" anchor="ctr"/>
+          <a:lstStyle/>
+          <a:p>
+            <a:r>
+              <a:rPr lang="ko-KR" altLang="en-US" sz="1200" smtClean="0">
+                <a:solidFill>
+                  <a:schemeClr val="tx1"/>
+                </a:solidFill>
+              </a:rPr>
+              <a:t>일기</a:t>
+            </a:r>
+            <a:endParaRPr lang="ko-KR" altLang="en-US" sz="1200">
+              <a:solidFill>
+                <a:schemeClr val="tx1"/>
+              </a:solidFill>
+            </a:endParaRPr>
+          </a:p>
+        </p:txBody>
+      </p:sp>
+      <p:sp>
+        <p:nvSpPr>
+          <p:cNvPr id="33" name="직사각형 32"/>
+          <p:cNvSpPr/>
+          <p:nvPr/>
+        </p:nvSpPr>
+        <p:spPr>
+          <a:xfrm>
+            <a:off x="1547664" y="2348880"/>
+            <a:ext cx="6048672" cy="2808312"/>
+          </a:xfrm>
+          <a:prstGeom prst="rect">
+            <a:avLst/>
+          </a:prstGeom>
+          <a:solidFill>
+            <a:schemeClr val="bg1">
+              <a:lumMod val="95000"/>
+            </a:schemeClr>
+          </a:solidFill>
+        </p:spPr>
+        <p:style>
+          <a:lnRef idx="2">
+            <a:schemeClr val="accent1">
+              <a:shade val="50000"/>
+            </a:schemeClr>
+          </a:lnRef>
+          <a:fillRef idx="1">
+            <a:schemeClr val="accent1"/>
+          </a:fillRef>
+          <a:effectRef idx="0">
+            <a:schemeClr val="accent1"/>
+          </a:effectRef>
+          <a:fontRef idx="minor">
+            <a:schemeClr val="lt1"/>
+          </a:fontRef>
+        </p:style>
+        <p:txBody>
+          <a:bodyPr rtlCol="0" anchor="ctr"/>
+          <a:lstStyle/>
+          <a:p>
+            <a:r>
+              <a:rPr lang="en-US" altLang="ko-KR" sz="1200" smtClean="0">
+                <a:solidFill>
+                  <a:schemeClr val="tx1"/>
+                </a:solidFill>
+              </a:rPr>
+              <a:t>(</a:t>
+            </a:r>
+            <a:r>
+              <a:rPr lang="ko-KR" altLang="en-US" sz="1200" smtClean="0">
+                <a:solidFill>
+                  <a:schemeClr val="tx1"/>
+                </a:solidFill>
+              </a:rPr>
+              <a:t>내용</a:t>
+            </a:r>
+            <a:r>
+              <a:rPr lang="en-US" altLang="ko-KR" sz="1200" smtClean="0">
+                <a:solidFill>
+                  <a:schemeClr val="tx1"/>
+                </a:solidFill>
+              </a:rPr>
+              <a:t>)</a:t>
+            </a:r>
+            <a:endParaRPr lang="ko-KR" altLang="en-US" sz="1200">
+              <a:solidFill>
+                <a:schemeClr val="tx1"/>
+              </a:solidFill>
+            </a:endParaRPr>
+          </a:p>
+        </p:txBody>
+      </p:sp>
+      <p:sp>
+        <p:nvSpPr>
+          <p:cNvPr id="34" name="직사각형 33"/>
+          <p:cNvSpPr/>
+          <p:nvPr/>
+        </p:nvSpPr>
+        <p:spPr>
+          <a:xfrm>
+            <a:off x="1547664" y="5445224"/>
+            <a:ext cx="288032" cy="266328"/>
+          </a:xfrm>
+          <a:prstGeom prst="rect">
+            <a:avLst/>
+          </a:prstGeom>
+          <a:solidFill>
+            <a:schemeClr val="bg1"/>
+          </a:solidFill>
+        </p:spPr>
+        <p:style>
+          <a:lnRef idx="2">
+            <a:schemeClr val="accent1">
+              <a:shade val="50000"/>
+            </a:schemeClr>
+          </a:lnRef>
+          <a:fillRef idx="1">
+            <a:schemeClr val="accent1"/>
+          </a:fillRef>
+          <a:effectRef idx="0">
+            <a:schemeClr val="accent1"/>
+          </a:effectRef>
+          <a:fontRef idx="minor">
+            <a:schemeClr val="lt1"/>
+          </a:fontRef>
+        </p:style>
+        <p:txBody>
+          <a:bodyPr rtlCol="0" anchor="ctr"/>
+          <a:lstStyle/>
+          <a:p>
+            <a:pPr algn="ctr"/>
+            <a:r>
+              <a:rPr lang="en-US" altLang="ko-KR" sz="1400" smtClean="0">
+                <a:solidFill>
+                  <a:schemeClr val="tx1"/>
+                </a:solidFill>
+              </a:rPr>
+              <a:t>V</a:t>
+            </a:r>
+            <a:endParaRPr lang="ko-KR" altLang="en-US" sz="1400">
+              <a:solidFill>
+                <a:schemeClr val="tx1"/>
+              </a:solidFill>
+            </a:endParaRPr>
+          </a:p>
+        </p:txBody>
+      </p:sp>
+      <p:sp>
+        <p:nvSpPr>
+          <p:cNvPr id="35" name="TextBox 34"/>
+          <p:cNvSpPr txBox="1"/>
+          <p:nvPr/>
+        </p:nvSpPr>
+        <p:spPr>
+          <a:xfrm>
+            <a:off x="1835696" y="5445224"/>
+            <a:ext cx="939681" cy="261610"/>
+          </a:xfrm>
+          <a:prstGeom prst="rect">
+            <a:avLst/>
+          </a:prstGeom>
+          <a:noFill/>
+        </p:spPr>
+        <p:txBody>
+          <a:bodyPr wrap="none" rtlCol="0">
+            <a:spAutoFit/>
+          </a:bodyPr>
+          <a:lstStyle/>
+          <a:p>
+            <a:r>
+              <a:rPr lang="ko-KR" altLang="en-US" sz="1100" smtClean="0"/>
+              <a:t>외부에 공개</a:t>
+            </a:r>
+            <a:endParaRPr lang="ko-KR" altLang="en-US" sz="1100"/>
+          </a:p>
+        </p:txBody>
+      </p:sp>
+    </p:spTree>
+  </p:cSld>
+  <p:clrMapOvr>
+    <a:masterClrMapping/>
+  </p:clrMapOvr>
+</p:sld>
+</file>
+
+<file path=ppt/slides/slide5.xml><?xml version="1.0" encoding="utf-8"?>
+<p:sld xmlns:a="http://schemas.openxmlformats.org/drawingml/2006/main" xmlns:r="http://schemas.openxmlformats.org/officeDocument/2006/relationships" xmlns:p="http://schemas.openxmlformats.org/presentationml/2006/main">
+  <p:cSld>
+    <p:spTree>
+      <p:nvGrpSpPr>
+        <p:cNvPr id="1" name=""/>
+        <p:cNvGrpSpPr/>
+        <p:nvPr/>
+      </p:nvGrpSpPr>
+      <p:grpSpPr>
+        <a:xfrm>
+          <a:off x="0" y="0"/>
+          <a:ext cx="0" cy="0"/>
+          <a:chOff x="0" y="0"/>
+          <a:chExt cx="0" cy="0"/>
+        </a:xfrm>
+      </p:grpSpPr>
+      <p:sp>
+        <p:nvSpPr>
+          <p:cNvPr id="4" name="직사각형 3"/>
+          <p:cNvSpPr/>
+          <p:nvPr/>
+        </p:nvSpPr>
+        <p:spPr>
+          <a:xfrm>
+            <a:off x="0" y="0"/>
+            <a:ext cx="2411760" cy="6858000"/>
+          </a:xfrm>
+          <a:prstGeom prst="rect">
+            <a:avLst/>
+          </a:prstGeom>
+        </p:spPr>
+        <p:style>
+          <a:lnRef idx="2">
+            <a:schemeClr val="accent6"/>
+          </a:lnRef>
+          <a:fillRef idx="1">
+            <a:schemeClr val="lt1"/>
+          </a:fillRef>
+          <a:effectRef idx="0">
+            <a:schemeClr val="accent6"/>
+          </a:effectRef>
+          <a:fontRef idx="minor">
+            <a:schemeClr val="dk1"/>
+          </a:fontRef>
+        </p:style>
+        <p:txBody>
+          <a:bodyPr rtlCol="0" anchor="ctr"/>
+          <a:lstStyle/>
+          <a:p>
+            <a:pPr algn="ctr"/>
+            <a:endParaRPr lang="ko-KR" altLang="en-US"/>
+          </a:p>
+        </p:txBody>
+      </p:sp>
+      <p:sp>
+        <p:nvSpPr>
+          <p:cNvPr id="5" name="타원 4"/>
+          <p:cNvSpPr/>
+          <p:nvPr/>
+        </p:nvSpPr>
+        <p:spPr>
+          <a:xfrm>
+            <a:off x="179512" y="6165304"/>
+            <a:ext cx="504056" cy="504056"/>
+          </a:xfrm>
+          <a:prstGeom prst="ellipse">
+            <a:avLst/>
+          </a:prstGeom>
+        </p:spPr>
+        <p:style>
+          <a:lnRef idx="2">
+            <a:schemeClr val="accent1">
+              <a:shade val="50000"/>
+            </a:schemeClr>
+          </a:lnRef>
+          <a:fillRef idx="1">
+            <a:schemeClr val="accent1"/>
+          </a:fillRef>
+          <a:effectRef idx="0">
+            <a:schemeClr val="accent1"/>
+          </a:effectRef>
+          <a:fontRef idx="minor">
+            <a:schemeClr val="lt1"/>
+          </a:fontRef>
+        </p:style>
+        <p:txBody>
+          <a:bodyPr rtlCol="0" anchor="ctr"/>
+          <a:lstStyle/>
+          <a:p>
+            <a:pPr algn="ctr"/>
+            <a:endParaRPr lang="ko-KR" altLang="en-US"/>
+          </a:p>
+        </p:txBody>
+      </p:sp>
+      <p:sp>
+        <p:nvSpPr>
+          <p:cNvPr id="6" name="TextBox 5"/>
+          <p:cNvSpPr txBox="1"/>
+          <p:nvPr/>
+        </p:nvSpPr>
+        <p:spPr>
+          <a:xfrm>
+            <a:off x="755576" y="6237312"/>
+            <a:ext cx="877163" cy="369332"/>
+          </a:xfrm>
+          <a:prstGeom prst="rect">
+            <a:avLst/>
+          </a:prstGeom>
+          <a:noFill/>
+        </p:spPr>
+        <p:txBody>
+          <a:bodyPr wrap="none" rtlCol="0">
+            <a:spAutoFit/>
+          </a:bodyPr>
+          <a:lstStyle/>
+          <a:p>
+            <a:r>
+              <a:rPr lang="ko-KR" altLang="en-US" smtClean="0"/>
+              <a:t>이민혁</a:t>
+            </a:r>
+            <a:endParaRPr lang="ko-KR" altLang="en-US"/>
+          </a:p>
+        </p:txBody>
+      </p:sp>
+      <p:sp>
+        <p:nvSpPr>
+          <p:cNvPr id="7" name="TextBox 6"/>
+          <p:cNvSpPr txBox="1"/>
+          <p:nvPr/>
+        </p:nvSpPr>
+        <p:spPr>
+          <a:xfrm>
+            <a:off x="107504" y="971436"/>
+            <a:ext cx="646331" cy="369332"/>
+          </a:xfrm>
+          <a:prstGeom prst="rect">
+            <a:avLst/>
+          </a:prstGeom>
+          <a:noFill/>
+        </p:spPr>
+        <p:txBody>
+          <a:bodyPr wrap="none" rtlCol="0">
+            <a:spAutoFit/>
+          </a:bodyPr>
+          <a:lstStyle/>
+          <a:p>
+            <a:r>
+              <a:rPr lang="ko-KR" altLang="en-US" b="1" smtClean="0"/>
+              <a:t>일기</a:t>
+            </a:r>
+            <a:endParaRPr lang="ko-KR" altLang="en-US" b="1"/>
+          </a:p>
+        </p:txBody>
+      </p:sp>
+      <p:sp>
+        <p:nvSpPr>
+          <p:cNvPr id="8" name="TextBox 7"/>
+          <p:cNvSpPr txBox="1"/>
+          <p:nvPr/>
+        </p:nvSpPr>
+        <p:spPr>
+          <a:xfrm>
+            <a:off x="179512" y="1403484"/>
+            <a:ext cx="415498" cy="369332"/>
+          </a:xfrm>
+          <a:prstGeom prst="rect">
+            <a:avLst/>
+          </a:prstGeom>
+          <a:noFill/>
+        </p:spPr>
+        <p:txBody>
+          <a:bodyPr wrap="none" rtlCol="0">
+            <a:spAutoFit/>
+          </a:bodyPr>
+          <a:lstStyle/>
+          <a:p>
+            <a:r>
+              <a:rPr lang="ko-KR" altLang="en-US" smtClean="0"/>
+              <a:t>글</a:t>
+            </a:r>
+            <a:endParaRPr lang="ko-KR" altLang="en-US"/>
+          </a:p>
+        </p:txBody>
+      </p:sp>
+      <p:sp>
+        <p:nvSpPr>
+          <p:cNvPr id="9" name="TextBox 8"/>
+          <p:cNvSpPr txBox="1"/>
+          <p:nvPr/>
+        </p:nvSpPr>
+        <p:spPr>
+          <a:xfrm>
+            <a:off x="2627784" y="404664"/>
+            <a:ext cx="1005403" cy="400110"/>
+          </a:xfrm>
+          <a:prstGeom prst="rect">
+            <a:avLst/>
+          </a:prstGeom>
+          <a:noFill/>
+        </p:spPr>
+        <p:txBody>
+          <a:bodyPr wrap="none" rtlCol="0">
+            <a:spAutoFit/>
+          </a:bodyPr>
+          <a:lstStyle/>
+          <a:p>
+            <a:r>
+              <a:rPr lang="en-US" altLang="ko-KR" sz="2000" smtClean="0"/>
+              <a:t>2026</a:t>
+            </a:r>
+            <a:r>
+              <a:rPr lang="ko-KR" altLang="en-US" sz="2000" smtClean="0"/>
+              <a:t>년</a:t>
+            </a:r>
+            <a:endParaRPr lang="ko-KR" altLang="en-US" sz="2000"/>
+          </a:p>
+        </p:txBody>
+      </p:sp>
+      <p:sp>
+        <p:nvSpPr>
+          <p:cNvPr id="10" name="TextBox 9"/>
+          <p:cNvSpPr txBox="1"/>
+          <p:nvPr/>
+        </p:nvSpPr>
+        <p:spPr>
+          <a:xfrm>
+            <a:off x="2843808" y="836712"/>
+            <a:ext cx="542136" cy="369332"/>
+          </a:xfrm>
+          <a:prstGeom prst="rect">
+            <a:avLst/>
+          </a:prstGeom>
+          <a:noFill/>
+        </p:spPr>
+        <p:txBody>
+          <a:bodyPr wrap="none" rtlCol="0">
+            <a:spAutoFit/>
+          </a:bodyPr>
+          <a:lstStyle/>
+          <a:p>
+            <a:r>
+              <a:rPr lang="en-US" altLang="ko-KR" smtClean="0"/>
+              <a:t>1</a:t>
+            </a:r>
+            <a:r>
+              <a:rPr lang="ko-KR" altLang="en-US" smtClean="0"/>
+              <a:t>월</a:t>
+            </a:r>
+            <a:endParaRPr lang="ko-KR" altLang="en-US"/>
+          </a:p>
+        </p:txBody>
+      </p:sp>
+      <p:sp>
+        <p:nvSpPr>
+          <p:cNvPr id="11" name="TextBox 10"/>
+          <p:cNvSpPr txBox="1"/>
+          <p:nvPr/>
+        </p:nvSpPr>
+        <p:spPr>
+          <a:xfrm>
+            <a:off x="3059832" y="1196752"/>
+            <a:ext cx="503664" cy="338554"/>
+          </a:xfrm>
+          <a:prstGeom prst="rect">
+            <a:avLst/>
+          </a:prstGeom>
+          <a:noFill/>
+        </p:spPr>
+        <p:txBody>
+          <a:bodyPr wrap="none" rtlCol="0">
+            <a:spAutoFit/>
+          </a:bodyPr>
+          <a:lstStyle/>
+          <a:p>
+            <a:r>
+              <a:rPr lang="en-US" altLang="ko-KR" sz="1600" smtClean="0"/>
+              <a:t>4</a:t>
+            </a:r>
+            <a:r>
+              <a:rPr lang="ko-KR" altLang="en-US" sz="1600" smtClean="0"/>
+              <a:t>일</a:t>
+            </a:r>
+            <a:endParaRPr lang="ko-KR" altLang="en-US" sz="1600"/>
+          </a:p>
+        </p:txBody>
+      </p:sp>
+      <p:sp>
+        <p:nvSpPr>
+          <p:cNvPr id="12" name="TextBox 11"/>
+          <p:cNvSpPr txBox="1"/>
+          <p:nvPr/>
+        </p:nvSpPr>
+        <p:spPr>
+          <a:xfrm>
+            <a:off x="3059832" y="2060848"/>
+            <a:ext cx="617477" cy="338554"/>
+          </a:xfrm>
+          <a:prstGeom prst="rect">
+            <a:avLst/>
+          </a:prstGeom>
+          <a:noFill/>
+        </p:spPr>
+        <p:txBody>
+          <a:bodyPr wrap="none" rtlCol="0">
+            <a:spAutoFit/>
+          </a:bodyPr>
+          <a:lstStyle/>
+          <a:p>
+            <a:r>
+              <a:rPr lang="en-US" altLang="ko-KR" sz="1600" smtClean="0"/>
+              <a:t>12</a:t>
+            </a:r>
+            <a:r>
+              <a:rPr lang="ko-KR" altLang="en-US" sz="1600" smtClean="0"/>
+              <a:t>일</a:t>
+            </a:r>
+            <a:endParaRPr lang="ko-KR" altLang="en-US" sz="1600"/>
+          </a:p>
+        </p:txBody>
+      </p:sp>
+      <p:sp>
+        <p:nvSpPr>
+          <p:cNvPr id="13" name="TextBox 12"/>
+          <p:cNvSpPr txBox="1"/>
+          <p:nvPr/>
+        </p:nvSpPr>
+        <p:spPr>
+          <a:xfrm>
+            <a:off x="3275856" y="1628800"/>
+            <a:ext cx="3728906" cy="307777"/>
+          </a:xfrm>
+          <a:prstGeom prst="rect">
+            <a:avLst/>
+          </a:prstGeom>
+          <a:noFill/>
+        </p:spPr>
+        <p:txBody>
+          <a:bodyPr wrap="none" rtlCol="0">
+            <a:spAutoFit/>
+          </a:bodyPr>
+          <a:lstStyle/>
+          <a:p>
+            <a:r>
+              <a:rPr lang="ko-KR" altLang="en-US" sz="1400" smtClean="0"/>
+              <a:t>새해 소원을 빌었는데 잘 이뤄질지 모르겠다</a:t>
+            </a:r>
+            <a:endParaRPr lang="ko-KR" altLang="en-US" sz="1400"/>
+          </a:p>
+        </p:txBody>
+      </p:sp>
+      <p:sp>
+        <p:nvSpPr>
+          <p:cNvPr id="14" name="TextBox 13"/>
+          <p:cNvSpPr txBox="1"/>
+          <p:nvPr/>
+        </p:nvSpPr>
+        <p:spPr>
+          <a:xfrm>
+            <a:off x="2771800" y="3212976"/>
+            <a:ext cx="542136" cy="369332"/>
+          </a:xfrm>
+          <a:prstGeom prst="rect">
+            <a:avLst/>
+          </a:prstGeom>
+          <a:noFill/>
+        </p:spPr>
+        <p:txBody>
+          <a:bodyPr wrap="none" rtlCol="0">
+            <a:spAutoFit/>
+          </a:bodyPr>
+          <a:lstStyle/>
+          <a:p>
+            <a:r>
+              <a:rPr lang="en-US" altLang="ko-KR" smtClean="0"/>
+              <a:t>2</a:t>
+            </a:r>
+            <a:r>
+              <a:rPr lang="ko-KR" altLang="en-US" smtClean="0"/>
+              <a:t>월</a:t>
+            </a:r>
+            <a:endParaRPr lang="ko-KR" altLang="en-US"/>
+          </a:p>
+        </p:txBody>
+      </p:sp>
+      <p:sp>
+        <p:nvSpPr>
+          <p:cNvPr id="15" name="TextBox 14"/>
+          <p:cNvSpPr txBox="1"/>
+          <p:nvPr/>
+        </p:nvSpPr>
+        <p:spPr>
+          <a:xfrm>
+            <a:off x="3275856" y="2420888"/>
+            <a:ext cx="1144865" cy="307777"/>
+          </a:xfrm>
+          <a:prstGeom prst="rect">
+            <a:avLst/>
+          </a:prstGeom>
+          <a:noFill/>
+        </p:spPr>
+        <p:txBody>
+          <a:bodyPr wrap="none" rtlCol="0">
+            <a:spAutoFit/>
+          </a:bodyPr>
+          <a:lstStyle/>
+          <a:p>
+            <a:r>
+              <a:rPr lang="ko-KR" altLang="en-US" sz="1400" smtClean="0"/>
+              <a:t>늦잠을 잤다</a:t>
+            </a:r>
+            <a:endParaRPr lang="ko-KR" altLang="en-US" sz="1400"/>
+          </a:p>
+        </p:txBody>
+      </p:sp>
+      <p:sp>
+        <p:nvSpPr>
+          <p:cNvPr id="16" name="TextBox 15"/>
+          <p:cNvSpPr txBox="1"/>
+          <p:nvPr/>
+        </p:nvSpPr>
+        <p:spPr>
+          <a:xfrm>
+            <a:off x="3059832" y="3645024"/>
+            <a:ext cx="617477" cy="338554"/>
+          </a:xfrm>
+          <a:prstGeom prst="rect">
+            <a:avLst/>
+          </a:prstGeom>
+          <a:noFill/>
+        </p:spPr>
+        <p:txBody>
+          <a:bodyPr wrap="none" rtlCol="0">
+            <a:spAutoFit/>
+          </a:bodyPr>
+          <a:lstStyle/>
+          <a:p>
+            <a:r>
+              <a:rPr lang="en-US" altLang="ko-KR" sz="1600" smtClean="0"/>
+              <a:t>15</a:t>
+            </a:r>
+            <a:r>
+              <a:rPr lang="ko-KR" altLang="en-US" sz="1600" smtClean="0"/>
+              <a:t>일</a:t>
+            </a:r>
+            <a:endParaRPr lang="ko-KR" altLang="en-US" sz="1600"/>
+          </a:p>
+        </p:txBody>
+      </p:sp>
+      <p:sp>
+        <p:nvSpPr>
+          <p:cNvPr id="17" name="TextBox 16"/>
+          <p:cNvSpPr txBox="1"/>
+          <p:nvPr/>
+        </p:nvSpPr>
+        <p:spPr>
+          <a:xfrm>
+            <a:off x="3275856" y="4077072"/>
+            <a:ext cx="3611886" cy="523220"/>
+          </a:xfrm>
+          <a:prstGeom prst="rect">
+            <a:avLst/>
+          </a:prstGeom>
+          <a:noFill/>
+        </p:spPr>
+        <p:txBody>
+          <a:bodyPr wrap="none" rtlCol="0">
+            <a:spAutoFit/>
+          </a:bodyPr>
+          <a:lstStyle/>
+          <a:p>
+            <a:r>
+              <a:rPr lang="ko-KR" altLang="en-US" sz="1400" smtClean="0"/>
+              <a:t>회사에서 일어나고 있는 일이 별로 마음에 </a:t>
+            </a:r>
+            <a:r>
+              <a:rPr lang="en-US" altLang="ko-KR" sz="1400" smtClean="0"/>
+              <a:t/>
+            </a:r>
+            <a:br>
+              <a:rPr lang="en-US" altLang="ko-KR" sz="1400" smtClean="0"/>
+            </a:br>
+            <a:r>
+              <a:rPr lang="ko-KR" altLang="en-US" sz="1400" smtClean="0"/>
+              <a:t>들지 않는다</a:t>
+            </a:r>
+            <a:endParaRPr lang="ko-KR" altLang="en-US" sz="1400"/>
+          </a:p>
+        </p:txBody>
+      </p:sp>
+      <p:sp>
+        <p:nvSpPr>
+          <p:cNvPr id="18" name="TextBox 17"/>
+          <p:cNvSpPr txBox="1"/>
+          <p:nvPr/>
+        </p:nvSpPr>
+        <p:spPr>
+          <a:xfrm>
+            <a:off x="6012160" y="6550223"/>
+            <a:ext cx="1612942" cy="307777"/>
+          </a:xfrm>
+          <a:prstGeom prst="rect">
+            <a:avLst/>
+          </a:prstGeom>
+          <a:noFill/>
+        </p:spPr>
+        <p:txBody>
+          <a:bodyPr wrap="none" rtlCol="0">
+            <a:spAutoFit/>
+          </a:bodyPr>
+          <a:lstStyle/>
+          <a:p>
+            <a:r>
+              <a:rPr lang="en-US" altLang="ko-KR" sz="1400" smtClean="0">
+                <a:solidFill>
+                  <a:srgbClr val="FF0000"/>
+                </a:solidFill>
+              </a:rPr>
+              <a:t>(</a:t>
+            </a:r>
+            <a:r>
+              <a:rPr lang="ko-KR" altLang="en-US" sz="1400" smtClean="0">
+                <a:solidFill>
+                  <a:srgbClr val="FF0000"/>
+                </a:solidFill>
+              </a:rPr>
+              <a:t>마크다운 컨텐츠</a:t>
+            </a:r>
+            <a:r>
+              <a:rPr lang="en-US" altLang="ko-KR" sz="1400" smtClean="0">
+                <a:solidFill>
+                  <a:srgbClr val="FF0000"/>
+                </a:solidFill>
+              </a:rPr>
+              <a:t>)</a:t>
+            </a:r>
+            <a:endParaRPr lang="ko-KR" altLang="en-US" sz="1400">
+              <a:solidFill>
+                <a:srgbClr val="FF0000"/>
+              </a:solidFill>
+            </a:endParaRPr>
+          </a:p>
+        </p:txBody>
+      </p:sp>
+      <p:sp>
+        <p:nvSpPr>
+          <p:cNvPr id="19" name="TextBox 18"/>
+          <p:cNvSpPr txBox="1"/>
+          <p:nvPr/>
+        </p:nvSpPr>
+        <p:spPr>
+          <a:xfrm>
+            <a:off x="1475656" y="6550223"/>
+            <a:ext cx="1011815" cy="307777"/>
+          </a:xfrm>
+          <a:prstGeom prst="rect">
+            <a:avLst/>
+          </a:prstGeom>
+          <a:noFill/>
+        </p:spPr>
+        <p:txBody>
+          <a:bodyPr wrap="none" rtlCol="0">
+            <a:spAutoFit/>
+          </a:bodyPr>
+          <a:lstStyle/>
+          <a:p>
+            <a:r>
+              <a:rPr lang="en-US" altLang="ko-KR" sz="1400" smtClean="0">
+                <a:solidFill>
+                  <a:srgbClr val="FF0000"/>
+                </a:solidFill>
+              </a:rPr>
+              <a:t>(</a:t>
+            </a:r>
+            <a:r>
+              <a:rPr lang="ko-KR" altLang="en-US" sz="1400" smtClean="0">
+                <a:solidFill>
+                  <a:srgbClr val="FF0000"/>
+                </a:solidFill>
+              </a:rPr>
+              <a:t>사이드바</a:t>
+            </a:r>
+            <a:r>
+              <a:rPr lang="en-US" altLang="ko-KR" sz="1400" smtClean="0">
+                <a:solidFill>
+                  <a:srgbClr val="FF0000"/>
+                </a:solidFill>
+              </a:rPr>
+              <a:t>)</a:t>
+            </a:r>
+            <a:endParaRPr lang="ko-KR" altLang="en-US" sz="1400">
+              <a:solidFill>
+                <a:srgbClr val="FF0000"/>
+              </a:solidFill>
+            </a:endParaRPr>
+          </a:p>
+        </p:txBody>
+      </p:sp>
+      <p:sp>
+        <p:nvSpPr>
+          <p:cNvPr id="20" name="직사각형 19"/>
+          <p:cNvSpPr/>
+          <p:nvPr/>
+        </p:nvSpPr>
+        <p:spPr>
+          <a:xfrm>
+            <a:off x="7668344" y="0"/>
+            <a:ext cx="1475656" cy="6858000"/>
+          </a:xfrm>
+          <a:prstGeom prst="rect">
+            <a:avLst/>
+          </a:prstGeom>
+        </p:spPr>
+        <p:style>
+          <a:lnRef idx="2">
+            <a:schemeClr val="accent6"/>
+          </a:lnRef>
+          <a:fillRef idx="1">
+            <a:schemeClr val="lt1"/>
+          </a:fillRef>
+          <a:effectRef idx="0">
+            <a:schemeClr val="accent6"/>
+          </a:effectRef>
+          <a:fontRef idx="minor">
+            <a:schemeClr val="dk1"/>
+          </a:fontRef>
+        </p:style>
+        <p:txBody>
+          <a:bodyPr rtlCol="0" anchor="t" anchorCtr="0"/>
+          <a:lstStyle/>
+          <a:p>
+            <a:endParaRPr lang="en-US" altLang="ko-KR" smtClean="0"/>
+          </a:p>
+          <a:p>
+            <a:endParaRPr lang="en-US" altLang="ko-KR" smtClean="0"/>
+          </a:p>
+          <a:p>
+            <a:endParaRPr lang="en-US" altLang="ko-KR" smtClean="0"/>
+          </a:p>
+          <a:p>
+            <a:endParaRPr lang="en-US" altLang="ko-KR" smtClean="0"/>
+          </a:p>
+          <a:p>
+            <a:r>
+              <a:rPr lang="en-US" altLang="ko-KR" smtClean="0"/>
+              <a:t>2026</a:t>
+            </a:r>
+            <a:r>
+              <a:rPr lang="ko-KR" altLang="en-US" smtClean="0"/>
+              <a:t>년</a:t>
+            </a:r>
+            <a:endParaRPr lang="en-US" altLang="ko-KR" smtClean="0"/>
+          </a:p>
+          <a:p>
+            <a:endParaRPr lang="en-US" altLang="ko-KR" smtClean="0"/>
+          </a:p>
+          <a:p>
+            <a:r>
+              <a:rPr lang="en-US" altLang="ko-KR" smtClean="0"/>
+              <a:t>2025</a:t>
+            </a:r>
+            <a:r>
+              <a:rPr lang="ko-KR" altLang="en-US" smtClean="0"/>
+              <a:t>년</a:t>
+            </a:r>
+            <a:endParaRPr lang="en-US" altLang="ko-KR" smtClean="0"/>
+          </a:p>
+          <a:p>
+            <a:endParaRPr lang="en-US" altLang="ko-KR" smtClean="0"/>
+          </a:p>
+          <a:p>
+            <a:r>
+              <a:rPr lang="en-US" altLang="ko-KR" smtClean="0"/>
+              <a:t>2024</a:t>
+            </a:r>
+            <a:r>
+              <a:rPr lang="ko-KR" altLang="en-US" smtClean="0"/>
+              <a:t>년</a:t>
+            </a:r>
+            <a:endParaRPr lang="en-US" altLang="ko-KR" smtClean="0"/>
+          </a:p>
+        </p:txBody>
+      </p:sp>
+      <p:sp>
+        <p:nvSpPr>
+          <p:cNvPr id="21" name="TextBox 20"/>
+          <p:cNvSpPr txBox="1"/>
+          <p:nvPr/>
+        </p:nvSpPr>
+        <p:spPr>
+          <a:xfrm>
+            <a:off x="7734640" y="6581001"/>
+            <a:ext cx="1409360" cy="276999"/>
+          </a:xfrm>
+          <a:prstGeom prst="rect">
+            <a:avLst/>
+          </a:prstGeom>
+          <a:noFill/>
+        </p:spPr>
+        <p:txBody>
+          <a:bodyPr wrap="none" rtlCol="0">
+            <a:spAutoFit/>
+          </a:bodyPr>
+          <a:lstStyle/>
+          <a:p>
+            <a:r>
+              <a:rPr lang="en-US" altLang="ko-KR" sz="1200" smtClean="0">
+                <a:solidFill>
+                  <a:srgbClr val="FF0000"/>
+                </a:solidFill>
+              </a:rPr>
+              <a:t>(</a:t>
+            </a:r>
+            <a:r>
+              <a:rPr lang="ko-KR" altLang="en-US" sz="1200" smtClean="0">
+                <a:solidFill>
+                  <a:srgbClr val="FF0000"/>
+                </a:solidFill>
+              </a:rPr>
+              <a:t>일기의 연도선택</a:t>
+            </a:r>
+            <a:r>
+              <a:rPr lang="en-US" altLang="ko-KR" sz="1200" smtClean="0">
+                <a:solidFill>
+                  <a:srgbClr val="FF0000"/>
+                </a:solidFill>
+              </a:rPr>
+              <a:t>)</a:t>
+            </a:r>
+            <a:endParaRPr lang="ko-KR" altLang="en-US" sz="1200">
+              <a:solidFill>
+                <a:srgbClr val="FF0000"/>
+              </a:solidFill>
+            </a:endParaRPr>
+          </a:p>
+        </p:txBody>
+      </p:sp>
+      <p:sp>
+        <p:nvSpPr>
+          <p:cNvPr id="23" name="TextBox 22"/>
+          <p:cNvSpPr txBox="1"/>
+          <p:nvPr/>
+        </p:nvSpPr>
+        <p:spPr>
+          <a:xfrm>
+            <a:off x="179512" y="611396"/>
+            <a:ext cx="415498" cy="369332"/>
+          </a:xfrm>
+          <a:prstGeom prst="rect">
+            <a:avLst/>
+          </a:prstGeom>
+          <a:noFill/>
+        </p:spPr>
+        <p:txBody>
+          <a:bodyPr wrap="none" rtlCol="0">
+            <a:spAutoFit/>
+          </a:bodyPr>
+          <a:lstStyle/>
+          <a:p>
+            <a:r>
               <a:rPr lang="ko-KR" altLang="en-US"/>
               <a:t>홈</a:t>
             </a:r>
+          </a:p>
+        </p:txBody>
+      </p:sp>
+      <p:sp>
+        <p:nvSpPr>
+          <p:cNvPr id="22" name="타원 21"/>
+          <p:cNvSpPr/>
+          <p:nvPr/>
+        </p:nvSpPr>
+        <p:spPr>
+          <a:xfrm>
+            <a:off x="7164288" y="6021288"/>
+            <a:ext cx="360040" cy="360040"/>
+          </a:xfrm>
+          <a:prstGeom prst="ellipse">
+            <a:avLst/>
+          </a:prstGeom>
+          <a:effectLst>
+            <a:outerShdw blurRad="50800" dist="38100" dir="2700000" algn="tl" rotWithShape="0">
+              <a:prstClr val="black">
+                <a:alpha val="40000"/>
+              </a:prstClr>
+            </a:outerShdw>
+          </a:effectLst>
+        </p:spPr>
+        <p:style>
+          <a:lnRef idx="2">
+            <a:schemeClr val="accent3"/>
+          </a:lnRef>
+          <a:fillRef idx="1">
+            <a:schemeClr val="lt1"/>
+          </a:fillRef>
+          <a:effectRef idx="0">
+            <a:schemeClr val="accent3"/>
+          </a:effectRef>
+          <a:fontRef idx="minor">
+            <a:schemeClr val="dk1"/>
+          </a:fontRef>
+        </p:style>
+        <p:txBody>
+          <a:bodyPr rtlCol="0" anchor="ctr"/>
+          <a:lstStyle/>
+          <a:p>
+            <a:pPr algn="ctr"/>
+            <a:r>
+              <a:rPr lang="en-US" altLang="ko-KR" smtClean="0"/>
+              <a:t>+</a:t>
+            </a:r>
+            <a:endParaRPr lang="ko-KR" altLang="en-US"/>
+          </a:p>
+        </p:txBody>
+      </p:sp>
+    </p:spTree>
+  </p:cSld>
+  <p:clrMapOvr>
+    <a:masterClrMapping/>
+  </p:clrMapOvr>
+</p:sld>
+</file>
+
+<file path=ppt/slides/slide6.xml><?xml version="1.0" encoding="utf-8"?>
+<p:sld xmlns:a="http://schemas.openxmlformats.org/drawingml/2006/main" xmlns:r="http://schemas.openxmlformats.org/officeDocument/2006/relationships" xmlns:p="http://schemas.openxmlformats.org/presentationml/2006/main">
+  <p:cSld>
+    <p:spTree>
+      <p:nvGrpSpPr>
+        <p:cNvPr id="1" name=""/>
+        <p:cNvGrpSpPr/>
+        <p:nvPr/>
+      </p:nvGrpSpPr>
+      <p:grpSpPr>
+        <a:xfrm>
+          <a:off x="0" y="0"/>
+          <a:ext cx="0" cy="0"/>
+          <a:chOff x="0" y="0"/>
+          <a:chExt cx="0" cy="0"/>
+        </a:xfrm>
+      </p:grpSpPr>
+      <p:sp>
+        <p:nvSpPr>
+          <p:cNvPr id="4" name="직사각형 3"/>
+          <p:cNvSpPr/>
+          <p:nvPr/>
+        </p:nvSpPr>
+        <p:spPr>
+          <a:xfrm>
+            <a:off x="0" y="0"/>
+            <a:ext cx="2411760" cy="6858000"/>
+          </a:xfrm>
+          <a:prstGeom prst="rect">
+            <a:avLst/>
+          </a:prstGeom>
+        </p:spPr>
+        <p:style>
+          <a:lnRef idx="2">
+            <a:schemeClr val="accent6"/>
+          </a:lnRef>
+          <a:fillRef idx="1">
+            <a:schemeClr val="lt1"/>
+          </a:fillRef>
+          <a:effectRef idx="0">
+            <a:schemeClr val="accent6"/>
+          </a:effectRef>
+          <a:fontRef idx="minor">
+            <a:schemeClr val="dk1"/>
+          </a:fontRef>
+        </p:style>
+        <p:txBody>
+          <a:bodyPr rtlCol="0" anchor="ctr"/>
+          <a:lstStyle/>
+          <a:p>
+            <a:pPr algn="ctr"/>
+            <a:endParaRPr lang="ko-KR" altLang="en-US"/>
+          </a:p>
+        </p:txBody>
+      </p:sp>
+      <p:sp>
+        <p:nvSpPr>
+          <p:cNvPr id="5" name="타원 4"/>
+          <p:cNvSpPr/>
+          <p:nvPr/>
+        </p:nvSpPr>
+        <p:spPr>
+          <a:xfrm>
+            <a:off x="179512" y="6165304"/>
+            <a:ext cx="504056" cy="504056"/>
+          </a:xfrm>
+          <a:prstGeom prst="ellipse">
+            <a:avLst/>
+          </a:prstGeom>
+        </p:spPr>
+        <p:style>
+          <a:lnRef idx="2">
+            <a:schemeClr val="accent1">
+              <a:shade val="50000"/>
+            </a:schemeClr>
+          </a:lnRef>
+          <a:fillRef idx="1">
+            <a:schemeClr val="accent1"/>
+          </a:fillRef>
+          <a:effectRef idx="0">
+            <a:schemeClr val="accent1"/>
+          </a:effectRef>
+          <a:fontRef idx="minor">
+            <a:schemeClr val="lt1"/>
+          </a:fontRef>
+        </p:style>
+        <p:txBody>
+          <a:bodyPr rtlCol="0" anchor="ctr"/>
+          <a:lstStyle/>
+          <a:p>
+            <a:pPr algn="ctr"/>
+            <a:endParaRPr lang="ko-KR" altLang="en-US"/>
+          </a:p>
+        </p:txBody>
+      </p:sp>
+      <p:sp>
+        <p:nvSpPr>
+          <p:cNvPr id="6" name="TextBox 5"/>
+          <p:cNvSpPr txBox="1"/>
+          <p:nvPr/>
+        </p:nvSpPr>
+        <p:spPr>
+          <a:xfrm>
+            <a:off x="755576" y="6237312"/>
+            <a:ext cx="877163" cy="369332"/>
+          </a:xfrm>
+          <a:prstGeom prst="rect">
+            <a:avLst/>
+          </a:prstGeom>
+          <a:noFill/>
+        </p:spPr>
+        <p:txBody>
+          <a:bodyPr wrap="none" rtlCol="0">
+            <a:spAutoFit/>
+          </a:bodyPr>
+          <a:lstStyle/>
+          <a:p>
+            <a:r>
+              <a:rPr lang="ko-KR" altLang="en-US" smtClean="0"/>
+              <a:t>이민혁</a:t>
+            </a:r>
+            <a:endParaRPr lang="ko-KR" altLang="en-US"/>
+          </a:p>
+        </p:txBody>
+      </p:sp>
+      <p:sp>
+        <p:nvSpPr>
+          <p:cNvPr id="7" name="TextBox 6"/>
+          <p:cNvSpPr txBox="1"/>
+          <p:nvPr/>
+        </p:nvSpPr>
+        <p:spPr>
+          <a:xfrm>
+            <a:off x="107504" y="971436"/>
+            <a:ext cx="646331" cy="369332"/>
+          </a:xfrm>
+          <a:prstGeom prst="rect">
+            <a:avLst/>
+          </a:prstGeom>
+          <a:noFill/>
+        </p:spPr>
+        <p:txBody>
+          <a:bodyPr wrap="none" rtlCol="0">
+            <a:spAutoFit/>
+          </a:bodyPr>
+          <a:lstStyle/>
+          <a:p>
+            <a:r>
+              <a:rPr lang="ko-KR" altLang="en-US" smtClean="0"/>
+              <a:t>일기</a:t>
+            </a:r>
+            <a:endParaRPr lang="ko-KR" altLang="en-US"/>
+          </a:p>
+        </p:txBody>
+      </p:sp>
+      <p:sp>
+        <p:nvSpPr>
+          <p:cNvPr id="8" name="TextBox 7"/>
+          <p:cNvSpPr txBox="1"/>
+          <p:nvPr/>
+        </p:nvSpPr>
+        <p:spPr>
+          <a:xfrm>
+            <a:off x="179512" y="1403484"/>
+            <a:ext cx="415498" cy="369332"/>
+          </a:xfrm>
+          <a:prstGeom prst="rect">
+            <a:avLst/>
+          </a:prstGeom>
+          <a:noFill/>
+        </p:spPr>
+        <p:txBody>
+          <a:bodyPr wrap="none" rtlCol="0">
+            <a:spAutoFit/>
+          </a:bodyPr>
+          <a:lstStyle/>
+          <a:p>
+            <a:r>
+              <a:rPr lang="ko-KR" altLang="en-US" b="1" smtClean="0"/>
+              <a:t>글</a:t>
+            </a:r>
+            <a:endParaRPr lang="ko-KR" altLang="en-US" b="1"/>
+          </a:p>
+        </p:txBody>
+      </p:sp>
+      <p:sp>
+        <p:nvSpPr>
+          <p:cNvPr id="9" name="TextBox 8"/>
+          <p:cNvSpPr txBox="1"/>
+          <p:nvPr/>
+        </p:nvSpPr>
+        <p:spPr>
+          <a:xfrm>
+            <a:off x="2627784" y="404664"/>
+            <a:ext cx="697627" cy="400110"/>
+          </a:xfrm>
+          <a:prstGeom prst="rect">
+            <a:avLst/>
+          </a:prstGeom>
+          <a:noFill/>
+        </p:spPr>
+        <p:txBody>
+          <a:bodyPr wrap="none" rtlCol="0">
+            <a:spAutoFit/>
+          </a:bodyPr>
+          <a:lstStyle/>
+          <a:p>
+            <a:r>
+              <a:rPr lang="ko-KR" altLang="en-US" sz="2000" smtClean="0"/>
+              <a:t>제목</a:t>
+            </a:r>
+            <a:endParaRPr lang="ko-KR" altLang="en-US" sz="2000"/>
+          </a:p>
+        </p:txBody>
+      </p:sp>
+      <p:sp>
+        <p:nvSpPr>
+          <p:cNvPr id="10" name="TextBox 9"/>
+          <p:cNvSpPr txBox="1"/>
+          <p:nvPr/>
+        </p:nvSpPr>
+        <p:spPr>
+          <a:xfrm>
+            <a:off x="2843808" y="836712"/>
+            <a:ext cx="646331" cy="369332"/>
+          </a:xfrm>
+          <a:prstGeom prst="rect">
+            <a:avLst/>
+          </a:prstGeom>
+          <a:noFill/>
+        </p:spPr>
+        <p:txBody>
+          <a:bodyPr wrap="none" rtlCol="0">
+            <a:spAutoFit/>
+          </a:bodyPr>
+          <a:lstStyle/>
+          <a:p>
+            <a:r>
+              <a:rPr lang="ko-KR" altLang="en-US" smtClean="0"/>
+              <a:t>내용</a:t>
+            </a:r>
+            <a:endParaRPr lang="ko-KR" altLang="en-US"/>
+          </a:p>
+        </p:txBody>
+      </p:sp>
+      <p:sp>
+        <p:nvSpPr>
+          <p:cNvPr id="18" name="TextBox 17"/>
+          <p:cNvSpPr txBox="1"/>
+          <p:nvPr/>
+        </p:nvSpPr>
+        <p:spPr>
+          <a:xfrm>
+            <a:off x="6012160" y="6550223"/>
+            <a:ext cx="1612942" cy="307777"/>
+          </a:xfrm>
+          <a:prstGeom prst="rect">
+            <a:avLst/>
+          </a:prstGeom>
+          <a:noFill/>
+        </p:spPr>
+        <p:txBody>
+          <a:bodyPr wrap="none" rtlCol="0">
+            <a:spAutoFit/>
+          </a:bodyPr>
+          <a:lstStyle/>
+          <a:p>
+            <a:r>
+              <a:rPr lang="en-US" altLang="ko-KR" sz="1400" smtClean="0">
+                <a:solidFill>
+                  <a:srgbClr val="FF0000"/>
+                </a:solidFill>
+              </a:rPr>
+              <a:t>(</a:t>
+            </a:r>
+            <a:r>
+              <a:rPr lang="ko-KR" altLang="en-US" sz="1400" smtClean="0">
+                <a:solidFill>
+                  <a:srgbClr val="FF0000"/>
+                </a:solidFill>
+              </a:rPr>
+              <a:t>마크다운 컨텐츠</a:t>
+            </a:r>
+            <a:r>
+              <a:rPr lang="en-US" altLang="ko-KR" sz="1400" smtClean="0">
+                <a:solidFill>
+                  <a:srgbClr val="FF0000"/>
+                </a:solidFill>
+              </a:rPr>
+              <a:t>)</a:t>
+            </a:r>
+            <a:endParaRPr lang="ko-KR" altLang="en-US" sz="1400">
+              <a:solidFill>
+                <a:srgbClr val="FF0000"/>
+              </a:solidFill>
+            </a:endParaRPr>
+          </a:p>
+        </p:txBody>
+      </p:sp>
+      <p:sp>
+        <p:nvSpPr>
+          <p:cNvPr id="19" name="TextBox 18"/>
+          <p:cNvSpPr txBox="1"/>
+          <p:nvPr/>
+        </p:nvSpPr>
+        <p:spPr>
+          <a:xfrm>
+            <a:off x="1475656" y="6550223"/>
+            <a:ext cx="1011815" cy="307777"/>
+          </a:xfrm>
+          <a:prstGeom prst="rect">
+            <a:avLst/>
+          </a:prstGeom>
+          <a:noFill/>
+        </p:spPr>
+        <p:txBody>
+          <a:bodyPr wrap="none" rtlCol="0">
+            <a:spAutoFit/>
+          </a:bodyPr>
+          <a:lstStyle/>
+          <a:p>
+            <a:r>
+              <a:rPr lang="en-US" altLang="ko-KR" sz="1400" smtClean="0">
+                <a:solidFill>
+                  <a:srgbClr val="FF0000"/>
+                </a:solidFill>
+              </a:rPr>
+              <a:t>(</a:t>
+            </a:r>
+            <a:r>
+              <a:rPr lang="ko-KR" altLang="en-US" sz="1400" smtClean="0">
+                <a:solidFill>
+                  <a:srgbClr val="FF0000"/>
+                </a:solidFill>
+              </a:rPr>
+              <a:t>사이드바</a:t>
+            </a:r>
+            <a:r>
+              <a:rPr lang="en-US" altLang="ko-KR" sz="1400" smtClean="0">
+                <a:solidFill>
+                  <a:srgbClr val="FF0000"/>
+                </a:solidFill>
+              </a:rPr>
+              <a:t>)</a:t>
+            </a:r>
+            <a:endParaRPr lang="ko-KR" altLang="en-US" sz="1400">
+              <a:solidFill>
+                <a:srgbClr val="FF0000"/>
+              </a:solidFill>
+            </a:endParaRPr>
+          </a:p>
+        </p:txBody>
+      </p:sp>
+      <p:sp>
+        <p:nvSpPr>
+          <p:cNvPr id="20" name="직사각형 19"/>
+          <p:cNvSpPr/>
+          <p:nvPr/>
+        </p:nvSpPr>
+        <p:spPr>
+          <a:xfrm>
+            <a:off x="7668344" y="0"/>
+            <a:ext cx="1475656" cy="6858000"/>
+          </a:xfrm>
+          <a:prstGeom prst="rect">
+            <a:avLst/>
+          </a:prstGeom>
+        </p:spPr>
+        <p:style>
+          <a:lnRef idx="2">
+            <a:schemeClr val="accent6"/>
+          </a:lnRef>
+          <a:fillRef idx="1">
+            <a:schemeClr val="lt1"/>
+          </a:fillRef>
+          <a:effectRef idx="0">
+            <a:schemeClr val="accent6"/>
+          </a:effectRef>
+          <a:fontRef idx="minor">
+            <a:schemeClr val="dk1"/>
+          </a:fontRef>
+        </p:style>
+        <p:txBody>
+          <a:bodyPr rtlCol="0" anchor="t" anchorCtr="0"/>
+          <a:lstStyle/>
+          <a:p>
+            <a:endParaRPr lang="en-US" altLang="ko-KR" smtClean="0"/>
+          </a:p>
+          <a:p>
+            <a:endParaRPr lang="en-US" altLang="ko-KR" smtClean="0"/>
+          </a:p>
+          <a:p>
+            <a:endParaRPr lang="en-US" altLang="ko-KR" smtClean="0"/>
+          </a:p>
+          <a:p>
+            <a:endParaRPr lang="en-US" altLang="ko-KR" smtClean="0"/>
+          </a:p>
+          <a:p>
+            <a:r>
+              <a:rPr lang="ko-KR" altLang="en-US" smtClean="0"/>
+              <a:t>독후감</a:t>
+            </a:r>
+            <a:endParaRPr lang="en-US" altLang="ko-KR" smtClean="0"/>
+          </a:p>
+          <a:p>
+            <a:endParaRPr lang="en-US" altLang="ko-KR" smtClean="0"/>
+          </a:p>
+          <a:p>
+            <a:r>
+              <a:rPr lang="ko-KR" altLang="en-US" smtClean="0"/>
+              <a:t>시승기</a:t>
+            </a:r>
+            <a:endParaRPr lang="en-US" altLang="ko-KR" smtClean="0"/>
+          </a:p>
+          <a:p>
+            <a:endParaRPr lang="en-US" altLang="ko-KR" smtClean="0"/>
+          </a:p>
+          <a:p>
+            <a:r>
+              <a:rPr lang="ko-KR" altLang="en-US" smtClean="0"/>
+              <a:t>기타</a:t>
+            </a:r>
+            <a:endParaRPr lang="en-US" altLang="ko-KR" smtClean="0"/>
+          </a:p>
+        </p:txBody>
+      </p:sp>
+      <p:sp>
+        <p:nvSpPr>
+          <p:cNvPr id="21" name="TextBox 20"/>
+          <p:cNvSpPr txBox="1"/>
+          <p:nvPr/>
+        </p:nvSpPr>
+        <p:spPr>
+          <a:xfrm>
+            <a:off x="7734640" y="6309320"/>
+            <a:ext cx="1471878" cy="461665"/>
+          </a:xfrm>
+          <a:prstGeom prst="rect">
+            <a:avLst/>
+          </a:prstGeom>
+          <a:noFill/>
+        </p:spPr>
+        <p:txBody>
+          <a:bodyPr wrap="none" rtlCol="0">
+            <a:spAutoFit/>
+          </a:bodyPr>
+          <a:lstStyle/>
+          <a:p>
+            <a:r>
+              <a:rPr lang="en-US" altLang="ko-KR" sz="1200" smtClean="0">
+                <a:solidFill>
+                  <a:srgbClr val="FF0000"/>
+                </a:solidFill>
+              </a:rPr>
+              <a:t>(</a:t>
+            </a:r>
+            <a:r>
+              <a:rPr lang="ko-KR" altLang="en-US" sz="1200" smtClean="0">
+                <a:solidFill>
+                  <a:srgbClr val="FF0000"/>
+                </a:solidFill>
+              </a:rPr>
+              <a:t>다른 글 카테고리 </a:t>
+            </a:r>
+            <a:r>
+              <a:rPr lang="en-US" altLang="ko-KR" sz="1200" smtClean="0">
+                <a:solidFill>
+                  <a:srgbClr val="FF0000"/>
+                </a:solidFill>
+              </a:rPr>
+              <a:t/>
+            </a:r>
+            <a:br>
+              <a:rPr lang="en-US" altLang="ko-KR" sz="1200" smtClean="0">
+                <a:solidFill>
+                  <a:srgbClr val="FF0000"/>
+                </a:solidFill>
+              </a:rPr>
+            </a:br>
+            <a:r>
+              <a:rPr lang="ko-KR" altLang="en-US" sz="1200" smtClean="0">
+                <a:solidFill>
+                  <a:srgbClr val="FF0000"/>
+                </a:solidFill>
+              </a:rPr>
+              <a:t>선택</a:t>
+            </a:r>
+            <a:r>
+              <a:rPr lang="en-US" altLang="ko-KR" sz="1200" smtClean="0">
+                <a:solidFill>
+                  <a:srgbClr val="FF0000"/>
+                </a:solidFill>
+              </a:rPr>
+              <a:t>)</a:t>
+            </a:r>
+            <a:endParaRPr lang="ko-KR" altLang="en-US" sz="1200">
+              <a:solidFill>
+                <a:srgbClr val="FF0000"/>
+              </a:solidFill>
+            </a:endParaRPr>
+          </a:p>
+        </p:txBody>
+      </p:sp>
+      <p:sp>
+        <p:nvSpPr>
+          <p:cNvPr id="23" name="TextBox 22"/>
+          <p:cNvSpPr txBox="1"/>
+          <p:nvPr/>
+        </p:nvSpPr>
+        <p:spPr>
+          <a:xfrm>
+            <a:off x="179512" y="611396"/>
+            <a:ext cx="415498" cy="369332"/>
+          </a:xfrm>
+          <a:prstGeom prst="rect">
+            <a:avLst/>
+          </a:prstGeom>
+          <a:noFill/>
+        </p:spPr>
+        <p:txBody>
+          <a:bodyPr wrap="none" rtlCol="0">
+            <a:spAutoFit/>
+          </a:bodyPr>
+          <a:lstStyle/>
+          <a:p>
+            <a:r>
+              <a:rPr lang="ko-KR" altLang="en-US"/>
+              <a:t>홈</a:t>
+            </a:r>
+          </a:p>
+        </p:txBody>
+      </p:sp>
+      <p:sp>
+        <p:nvSpPr>
+          <p:cNvPr id="14" name="타원 13"/>
+          <p:cNvSpPr/>
+          <p:nvPr/>
+        </p:nvSpPr>
+        <p:spPr>
+          <a:xfrm>
+            <a:off x="7164288" y="6021288"/>
+            <a:ext cx="360040" cy="360040"/>
+          </a:xfrm>
+          <a:prstGeom prst="ellipse">
+            <a:avLst/>
+          </a:prstGeom>
+          <a:effectLst>
+            <a:outerShdw blurRad="50800" dist="38100" dir="2700000" algn="tl" rotWithShape="0">
+              <a:prstClr val="black">
+                <a:alpha val="40000"/>
+              </a:prstClr>
+            </a:outerShdw>
+          </a:effectLst>
+        </p:spPr>
+        <p:style>
+          <a:lnRef idx="2">
+            <a:schemeClr val="accent3"/>
+          </a:lnRef>
+          <a:fillRef idx="1">
+            <a:schemeClr val="lt1"/>
+          </a:fillRef>
+          <a:effectRef idx="0">
+            <a:schemeClr val="accent3"/>
+          </a:effectRef>
+          <a:fontRef idx="minor">
+            <a:schemeClr val="dk1"/>
+          </a:fontRef>
+        </p:style>
+        <p:txBody>
+          <a:bodyPr rtlCol="0" anchor="ctr"/>
+          <a:lstStyle/>
+          <a:p>
+            <a:pPr algn="ctr"/>
+            <a:r>
+              <a:rPr lang="en-US" altLang="ko-KR" smtClean="0"/>
+              <a:t>+</a:t>
+            </a:r>
+            <a:endParaRPr lang="ko-KR" altLang="en-US"/>
           </a:p>
         </p:txBody>
       </p:sp>

</xml_diff>

<commit_message>
user listing, category add/delete feature added
</commit_message>
<xml_diff>
--- a/note/frontend_page_plan.pptx
+++ b/note/frontend_page_plan.pptx
@@ -198,7 +198,7 @@
             <a:fld id="{C7B2C064-4715-42BE-8447-58F43F0E67E0}" type="datetimeFigureOut">
               <a:rPr lang="ko-KR" altLang="en-US" smtClean="0"/>
               <a:pPr/>
-              <a:t>2026-05-10</a:t>
+              <a:t>2026-05-16</a:t>
             </a:fld>
             <a:endParaRPr lang="ko-KR" altLang="en-US"/>
           </a:p>
@@ -1371,7 +1371,7 @@
             <a:fld id="{49BCE5CC-EAE8-48BE-852D-E6A066A35CB1}" type="datetimeFigureOut">
               <a:rPr lang="ko-KR" altLang="en-US" smtClean="0"/>
               <a:pPr/>
-              <a:t>2026-05-10</a:t>
+              <a:t>2026-05-16</a:t>
             </a:fld>
             <a:endParaRPr lang="ko-KR" altLang="en-US"/>
           </a:p>
@@ -1538,7 +1538,7 @@
             <a:fld id="{49BCE5CC-EAE8-48BE-852D-E6A066A35CB1}" type="datetimeFigureOut">
               <a:rPr lang="ko-KR" altLang="en-US" smtClean="0"/>
               <a:pPr/>
-              <a:t>2026-05-10</a:t>
+              <a:t>2026-05-16</a:t>
             </a:fld>
             <a:endParaRPr lang="ko-KR" altLang="en-US"/>
           </a:p>
@@ -1715,7 +1715,7 @@
             <a:fld id="{49BCE5CC-EAE8-48BE-852D-E6A066A35CB1}" type="datetimeFigureOut">
               <a:rPr lang="ko-KR" altLang="en-US" smtClean="0"/>
               <a:pPr/>
-              <a:t>2026-05-10</a:t>
+              <a:t>2026-05-16</a:t>
             </a:fld>
             <a:endParaRPr lang="ko-KR" altLang="en-US"/>
           </a:p>
@@ -1882,7 +1882,7 @@
             <a:fld id="{49BCE5CC-EAE8-48BE-852D-E6A066A35CB1}" type="datetimeFigureOut">
               <a:rPr lang="ko-KR" altLang="en-US" smtClean="0"/>
               <a:pPr/>
-              <a:t>2026-05-10</a:t>
+              <a:t>2026-05-16</a:t>
             </a:fld>
             <a:endParaRPr lang="ko-KR" altLang="en-US"/>
           </a:p>
@@ -2125,7 +2125,7 @@
             <a:fld id="{49BCE5CC-EAE8-48BE-852D-E6A066A35CB1}" type="datetimeFigureOut">
               <a:rPr lang="ko-KR" altLang="en-US" smtClean="0"/>
               <a:pPr/>
-              <a:t>2026-05-10</a:t>
+              <a:t>2026-05-16</a:t>
             </a:fld>
             <a:endParaRPr lang="ko-KR" altLang="en-US"/>
           </a:p>
@@ -2410,7 +2410,7 @@
             <a:fld id="{49BCE5CC-EAE8-48BE-852D-E6A066A35CB1}" type="datetimeFigureOut">
               <a:rPr lang="ko-KR" altLang="en-US" smtClean="0"/>
               <a:pPr/>
-              <a:t>2026-05-10</a:t>
+              <a:t>2026-05-16</a:t>
             </a:fld>
             <a:endParaRPr lang="ko-KR" altLang="en-US"/>
           </a:p>
@@ -2829,7 +2829,7 @@
             <a:fld id="{49BCE5CC-EAE8-48BE-852D-E6A066A35CB1}" type="datetimeFigureOut">
               <a:rPr lang="ko-KR" altLang="en-US" smtClean="0"/>
               <a:pPr/>
-              <a:t>2026-05-10</a:t>
+              <a:t>2026-05-16</a:t>
             </a:fld>
             <a:endParaRPr lang="ko-KR" altLang="en-US"/>
           </a:p>
@@ -2944,7 +2944,7 @@
             <a:fld id="{49BCE5CC-EAE8-48BE-852D-E6A066A35CB1}" type="datetimeFigureOut">
               <a:rPr lang="ko-KR" altLang="en-US" smtClean="0"/>
               <a:pPr/>
-              <a:t>2026-05-10</a:t>
+              <a:t>2026-05-16</a:t>
             </a:fld>
             <a:endParaRPr lang="ko-KR" altLang="en-US"/>
           </a:p>
@@ -3036,7 +3036,7 @@
             <a:fld id="{49BCE5CC-EAE8-48BE-852D-E6A066A35CB1}" type="datetimeFigureOut">
               <a:rPr lang="ko-KR" altLang="en-US" smtClean="0"/>
               <a:pPr/>
-              <a:t>2026-05-10</a:t>
+              <a:t>2026-05-16</a:t>
             </a:fld>
             <a:endParaRPr lang="ko-KR" altLang="en-US"/>
           </a:p>
@@ -3310,7 +3310,7 @@
             <a:fld id="{49BCE5CC-EAE8-48BE-852D-E6A066A35CB1}" type="datetimeFigureOut">
               <a:rPr lang="ko-KR" altLang="en-US" smtClean="0"/>
               <a:pPr/>
-              <a:t>2026-05-10</a:t>
+              <a:t>2026-05-16</a:t>
             </a:fld>
             <a:endParaRPr lang="ko-KR" altLang="en-US"/>
           </a:p>
@@ -3560,7 +3560,7 @@
             <a:fld id="{49BCE5CC-EAE8-48BE-852D-E6A066A35CB1}" type="datetimeFigureOut">
               <a:rPr lang="ko-KR" altLang="en-US" smtClean="0"/>
               <a:pPr/>
-              <a:t>2026-05-10</a:t>
+              <a:t>2026-05-16</a:t>
             </a:fld>
             <a:endParaRPr lang="ko-KR" altLang="en-US"/>
           </a:p>
@@ -3770,7 +3770,7 @@
             <a:fld id="{49BCE5CC-EAE8-48BE-852D-E6A066A35CB1}" type="datetimeFigureOut">
               <a:rPr lang="ko-KR" altLang="en-US" smtClean="0"/>
               <a:pPr/>
-              <a:t>2026-05-10</a:t>
+              <a:t>2026-05-16</a:t>
             </a:fld>
             <a:endParaRPr lang="ko-KR" altLang="en-US"/>
           </a:p>
@@ -7101,15 +7101,7 @@
                   <a:schemeClr val="tx1"/>
                 </a:solidFill>
               </a:rPr>
-              <a:t> </a:t>
-            </a:r>
-            <a:r>
-              <a:rPr lang="en-US" altLang="ko-KR" sz="1200" smtClean="0">
-                <a:solidFill>
-                  <a:schemeClr val="tx1"/>
-                </a:solidFill>
-              </a:rPr>
-              <a:t>– </a:t>
+              <a:t> – </a:t>
             </a:r>
             <a:r>
               <a:rPr lang="ko-KR" altLang="en-US" sz="1200" smtClean="0">

</xml_diff>